<commit_message>
docs: JEV 簡報 python-pptx 版改 MP072 配色並修正 wipe 動畫方向
- build_pptx.py 改用 ppt-master pptx_fx 的 animate、fx、transition（664 行減到 506 行），PowerPoint 讀到的轉場與動畫跟重構前一致
- 配色改 MP072（深藍＋橘）；亮卡改近不透明深藍底，避免光暈透色壓低文字對比
- wipe 進場濾鏡原本整組寫反，對照 PowerPoint 存出的 XML 後修正
- 重產 pptx、qa 截圖、icon；brief.md 加第 6 節、工具筆記與比較報告補上 10/06 後續

Co-Authored-By: Claude Opus 5.5 <noreply@anthropic.com>
</commit_message>
<xml_diff>
--- a/docs/slides/JEV儀表板_python-pptx.pptx
+++ b/docs/slides/JEV儀表板_python-pptx.pptx
@@ -143,7 +143,7 @@
           </c:tx>
           <c:spPr>
             <a:solidFill>
-              <a:srgbClr val="FFFFFF">
+              <a:srgbClr val="EEE9DF">
                 <a:alpha val="70000"/>
               </a:srgbClr>
             </a:solidFill>
@@ -194,7 +194,7 @@
           </c:tx>
           <c:spPr>
             <a:solidFill>
-              <a:srgbClr val="00F2FE"/>
+              <a:srgbClr val="FFB162"/>
             </a:solidFill>
           </c:spPr>
           <c:cat>
@@ -236,7 +236,7 @@
               <a:pPr>
                 <a:defRPr sz="1200">
                   <a:solidFill>
-                    <a:srgbClr val="FFFFFF"/>
+                    <a:srgbClr val="EEE9DF"/>
                   </a:solidFill>
                 </a:defRPr>
               </a:pPr>
@@ -269,7 +269,7 @@
         <c:spPr>
           <a:ln>
             <a:solidFill>
-              <a:srgbClr val="FFFFFF">
+              <a:srgbClr val="EEE9DF">
                 <a:alpha val="25000"/>
               </a:srgbClr>
             </a:solidFill>
@@ -291,7 +291,7 @@
           <c:spPr>
             <a:ln w="9525">
               <a:solidFill>
-                <a:srgbClr val="FFFFFF">
+                <a:srgbClr val="EEE9DF">
                   <a:alpha val="15000"/>
                 </a:srgbClr>
               </a:solidFill>
@@ -335,7 +335,7 @@
       <a:pPr>
         <a:defRPr sz="1100">
           <a:solidFill>
-            <a:srgbClr val="D6D3F0"/>
+            <a:srgbClr val="C9C1B1"/>
           </a:solidFill>
           <a:latin typeface="Noto Sans TC"/>
           <a:ea typeface="Noto Sans TC"/>
@@ -4520,10 +4520,10 @@
         <a:gradFill rotWithShape="1">
           <a:gsLst>
             <a:gs pos="0">
-              <a:srgbClr val="1F1C5C"/>
+              <a:srgbClr val="1B2632"/>
             </a:gs>
             <a:gs pos="100000">
-              <a:srgbClr val="5B1F6E"/>
+              <a:srgbClr val="2C3B4D"/>
             </a:gs>
           </a:gsLst>
           <a:lin scaled="0" ang="2700000"/>
@@ -4540,7 +4540,7 @@
       <p:grpSpPr/>
       <p:sp>
         <p:nvSpPr>
-          <p:cNvPr id="2" name="!!orb-violet"/>
+          <p:cNvPr id="2" name="!!orb-orange"/>
           <p:cNvSpPr/>
           <p:nvPr/>
         </p:nvSpPr>
@@ -4553,8 +4553,8 @@
             <a:avLst/>
           </a:prstGeom>
           <a:solidFill>
-            <a:srgbClr val="667EEA">
-              <a:alpha val="55000"/>
+            <a:srgbClr val="FFB162">
+              <a:alpha val="35000"/>
             </a:srgbClr>
           </a:solidFill>
           <a:ln>
@@ -4574,7 +4574,7 @@
       </p:sp>
       <p:sp>
         <p:nvSpPr>
-          <p:cNvPr id="3" name="!!orb-pink"/>
+          <p:cNvPr id="3" name="!!orb-rust"/>
           <p:cNvSpPr/>
           <p:nvPr/>
         </p:nvSpPr>
@@ -4587,8 +4587,8 @@
             <a:avLst/>
           </a:prstGeom>
           <a:solidFill>
-            <a:srgbClr val="F093FB">
-              <a:alpha val="45000"/>
+            <a:srgbClr val="A35139">
+              <a:alpha val="55000"/>
             </a:srgbClr>
           </a:solidFill>
           <a:ln>
@@ -4608,7 +4608,7 @@
       </p:sp>
       <p:sp>
         <p:nvSpPr>
-          <p:cNvPr id="4" name="!!orb-cyan"/>
+          <p:cNvPr id="4" name="!!orb-cream"/>
           <p:cNvSpPr/>
           <p:nvPr/>
         </p:nvSpPr>
@@ -4621,8 +4621,8 @@
             <a:avLst/>
           </a:prstGeom>
           <a:solidFill>
-            <a:srgbClr val="00F2FE">
-              <a:alpha val="30000"/>
+            <a:srgbClr val="EEE9DF">
+              <a:alpha val="12000"/>
             </a:srgbClr>
           </a:solidFill>
           <a:ln>
@@ -4657,13 +4657,13 @@
             </a:avLst>
           </a:prstGeom>
           <a:solidFill>
-            <a:srgbClr val="FFFFFF">
+            <a:srgbClr val="EEE9DF">
               <a:alpha val="12000"/>
             </a:srgbClr>
           </a:solidFill>
           <a:ln w="9525">
             <a:solidFill>
-              <a:srgbClr val="FFFFFF">
+              <a:srgbClr val="EEE9DF">
                 <a:alpha val="35000"/>
               </a:srgbClr>
             </a:solidFill>
@@ -4710,7 +4710,7 @@
             <a:r>
               <a:rPr sz="1600" b="1" lang="zh-TW" spc="300">
                 <a:solidFill>
-                  <a:srgbClr val="00F2FE"/>
+                  <a:srgbClr val="FFB162"/>
                 </a:solidFill>
                 <a:latin typeface="Noto Sans TC"/>
                 <a:ea typeface="Noto Sans TC"/>
@@ -4751,7 +4751,7 @@
             <a:r>
               <a:rPr sz="5400" b="1" lang="zh-TW">
                 <a:solidFill>
-                  <a:srgbClr val="FFFFFF"/>
+                  <a:srgbClr val="EEE9DF"/>
                 </a:solidFill>
                 <a:effectLst>
                   <a:outerShdw blurRad="50800" dist="19050" dir="5400000" algn="ctr" rotWithShape="0">
@@ -4776,7 +4776,7 @@
             <a:r>
               <a:rPr sz="5400" b="1" lang="zh-TW">
                 <a:solidFill>
-                  <a:srgbClr val="FFFFFF"/>
+                  <a:srgbClr val="EEE9DF"/>
                 </a:solidFill>
                 <a:effectLst>
                   <a:outerShdw blurRad="50800" dist="19050" dir="5400000" algn="ctr" rotWithShape="0">
@@ -4820,7 +4820,7 @@
             <a:r>
               <a:rPr sz="1600" b="1" lang="zh-TW">
                 <a:solidFill>
-                  <a:srgbClr val="D6D3F0"/>
+                  <a:srgbClr val="C9C1B1"/>
                 </a:solidFill>
                 <a:latin typeface="Noto Sans TC"/>
                 <a:ea typeface="Noto Sans TC"/>
@@ -4857,7 +4857,7 @@
             <a:r>
               <a:rPr sz="1050" b="0" lang="zh-TW">
                 <a:solidFill>
-                  <a:srgbClr val="D6D3F0"/>
+                  <a:srgbClr val="C9C1B1"/>
                 </a:solidFill>
                 <a:latin typeface="Noto Sans TC"/>
                 <a:ea typeface="Noto Sans TC"/>
@@ -5092,7 +5092,7 @@
                                         <p:strVal val="visible"/>
                                       </p:to>
                                     </p:set>
-                                    <p:animEffect transition="in" filter="wipe(right)">
+                                    <p:animEffect transition="in" filter="wipe(left)">
                                       <p:cBhvr>
                                         <p:cTn id="20" dur="400"/>
                                         <p:tgtEl>
@@ -5193,10 +5193,10 @@
         <a:gradFill rotWithShape="1">
           <a:gsLst>
             <a:gs pos="0">
-              <a:srgbClr val="1F1C5C"/>
+              <a:srgbClr val="1B2632"/>
             </a:gs>
             <a:gs pos="100000">
-              <a:srgbClr val="5B1F6E"/>
+              <a:srgbClr val="2C3B4D"/>
             </a:gs>
           </a:gsLst>
           <a:lin scaled="0" ang="2700000"/>
@@ -5213,7 +5213,7 @@
       <p:grpSpPr/>
       <p:sp>
         <p:nvSpPr>
-          <p:cNvPr id="2" name="!!orb-violet"/>
+          <p:cNvPr id="2" name="!!orb-orange"/>
           <p:cNvSpPr/>
           <p:nvPr/>
         </p:nvSpPr>
@@ -5226,7 +5226,41 @@
             <a:avLst/>
           </a:prstGeom>
           <a:solidFill>
-            <a:srgbClr val="667EEA">
+            <a:srgbClr val="FFB162">
+              <a:alpha val="35000"/>
+            </a:srgbClr>
+          </a:solidFill>
+          <a:ln>
+            <a:noFill/>
+          </a:ln>
+          <a:effectLst>
+            <a:softEdge rad="777240"/>
+          </a:effectLst>
+        </p:spPr>
+        <p:txBody>
+          <a:bodyPr rtlCol="0" anchor="ctr"/>
+          <a:lstStyle/>
+          <a:p>
+            <a:pPr algn="ctr"/>
+          </a:p>
+        </p:txBody>
+      </p:sp>
+      <p:sp>
+        <p:nvSpPr>
+          <p:cNvPr id="3" name="!!orb-rust"/>
+          <p:cNvSpPr/>
+          <p:nvPr/>
+        </p:nvSpPr>
+        <p:spPr>
+          <a:xfrm>
+            <a:off x="7772400" y="91440"/>
+            <a:ext cx="3108960" cy="3108960"/>
+          </a:xfrm>
+          <a:prstGeom prst="ellipse">
+            <a:avLst/>
+          </a:prstGeom>
+          <a:solidFill>
+            <a:srgbClr val="A35139">
               <a:alpha val="55000"/>
             </a:srgbClr>
           </a:solidFill>
@@ -5247,41 +5281,7 @@
       </p:sp>
       <p:sp>
         <p:nvSpPr>
-          <p:cNvPr id="3" name="!!orb-pink"/>
-          <p:cNvSpPr/>
-          <p:nvPr/>
-        </p:nvSpPr>
-        <p:spPr>
-          <a:xfrm>
-            <a:off x="7772400" y="91440"/>
-            <a:ext cx="3108960" cy="3108960"/>
-          </a:xfrm>
-          <a:prstGeom prst="ellipse">
-            <a:avLst/>
-          </a:prstGeom>
-          <a:solidFill>
-            <a:srgbClr val="F093FB">
-              <a:alpha val="45000"/>
-            </a:srgbClr>
-          </a:solidFill>
-          <a:ln>
-            <a:noFill/>
-          </a:ln>
-          <a:effectLst>
-            <a:softEdge rad="777240"/>
-          </a:effectLst>
-        </p:spPr>
-        <p:txBody>
-          <a:bodyPr rtlCol="0" anchor="ctr"/>
-          <a:lstStyle/>
-          <a:p>
-            <a:pPr algn="ctr"/>
-          </a:p>
-        </p:txBody>
-      </p:sp>
-      <p:sp>
-        <p:nvSpPr>
-          <p:cNvPr id="4" name="!!orb-cyan"/>
+          <p:cNvPr id="4" name="!!orb-cream"/>
           <p:cNvSpPr/>
           <p:nvPr/>
         </p:nvSpPr>
@@ -5294,8 +5294,8 @@
             <a:avLst/>
           </a:prstGeom>
           <a:solidFill>
-            <a:srgbClr val="00F2FE">
-              <a:alpha val="30000"/>
+            <a:srgbClr val="EEE9DF">
+              <a:alpha val="12000"/>
             </a:srgbClr>
           </a:solidFill>
           <a:ln>
@@ -5339,7 +5339,7 @@
             <a:r>
               <a:rPr sz="2600" b="1" lang="zh-TW">
                 <a:solidFill>
-                  <a:srgbClr val="FFFFFF"/>
+                  <a:srgbClr val="EEE9DF"/>
                 </a:solidFill>
                 <a:effectLst>
                   <a:outerShdw blurRad="50800" dist="19050" dir="5400000" algn="ctr" rotWithShape="0">
@@ -5383,7 +5383,7 @@
             <a:r>
               <a:rPr sz="1050" b="0" lang="zh-TW">
                 <a:solidFill>
-                  <a:srgbClr val="D6D3F0"/>
+                  <a:srgbClr val="C9C1B1"/>
                 </a:solidFill>
                 <a:latin typeface="Noto Sans TC"/>
                 <a:ea typeface="Noto Sans TC"/>
@@ -5420,7 +5420,7 @@
             <a:r>
               <a:rPr sz="1050" b="0" lang="zh-TW">
                 <a:solidFill>
-                  <a:srgbClr val="D6D3F0"/>
+                  <a:srgbClr val="C9C1B1"/>
                 </a:solidFill>
                 <a:latin typeface="Noto Sans TC"/>
                 <a:ea typeface="Noto Sans TC"/>
@@ -5448,13 +5448,13 @@
             </a:avLst>
           </a:prstGeom>
           <a:solidFill>
-            <a:srgbClr val="FFFFFF">
+            <a:srgbClr val="EEE9DF">
               <a:alpha val="12000"/>
             </a:srgbClr>
           </a:solidFill>
           <a:ln w="9525">
             <a:solidFill>
-              <a:srgbClr val="FFFFFF">
+              <a:srgbClr val="EEE9DF">
                 <a:alpha val="35000"/>
               </a:srgbClr>
             </a:solidFill>
@@ -5525,7 +5525,7 @@
             <a:r>
               <a:rPr sz="1600" b="1" lang="zh-TW">
                 <a:solidFill>
-                  <a:srgbClr val="FFFFFF"/>
+                  <a:srgbClr val="EEE9DF"/>
                 </a:solidFill>
                 <a:latin typeface="Noto Sans TC"/>
                 <a:ea typeface="Noto Sans TC"/>
@@ -5562,7 +5562,7 @@
             <a:r>
               <a:rPr sz="1400" b="0" lang="zh-TW">
                 <a:solidFill>
-                  <a:srgbClr val="D6D3F0"/>
+                  <a:srgbClr val="C9C1B1"/>
                 </a:solidFill>
                 <a:latin typeface="Noto Sans TC"/>
                 <a:ea typeface="Noto Sans TC"/>
@@ -5590,13 +5590,13 @@
             </a:avLst>
           </a:prstGeom>
           <a:solidFill>
-            <a:srgbClr val="FFFFFF">
+            <a:srgbClr val="EEE9DF">
               <a:alpha val="12000"/>
             </a:srgbClr>
           </a:solidFill>
           <a:ln w="9525">
             <a:solidFill>
-              <a:srgbClr val="FFFFFF">
+              <a:srgbClr val="EEE9DF">
                 <a:alpha val="35000"/>
               </a:srgbClr>
             </a:solidFill>
@@ -5667,7 +5667,7 @@
             <a:r>
               <a:rPr sz="1600" b="1" lang="zh-TW">
                 <a:solidFill>
-                  <a:srgbClr val="FFFFFF"/>
+                  <a:srgbClr val="EEE9DF"/>
                 </a:solidFill>
                 <a:latin typeface="Noto Sans TC"/>
                 <a:ea typeface="Noto Sans TC"/>
@@ -5704,7 +5704,7 @@
             <a:r>
               <a:rPr sz="1400" b="0" lang="zh-TW">
                 <a:solidFill>
-                  <a:srgbClr val="D6D3F0"/>
+                  <a:srgbClr val="C9C1B1"/>
                 </a:solidFill>
                 <a:latin typeface="Noto Sans TC"/>
                 <a:ea typeface="Noto Sans TC"/>
@@ -5732,13 +5732,13 @@
             </a:avLst>
           </a:prstGeom>
           <a:solidFill>
-            <a:srgbClr val="FFFFFF">
+            <a:srgbClr val="EEE9DF">
               <a:alpha val="12000"/>
             </a:srgbClr>
           </a:solidFill>
           <a:ln w="9525">
             <a:solidFill>
-              <a:srgbClr val="FFFFFF">
+              <a:srgbClr val="EEE9DF">
                 <a:alpha val="35000"/>
               </a:srgbClr>
             </a:solidFill>
@@ -5809,7 +5809,7 @@
             <a:r>
               <a:rPr sz="1600" b="1" lang="zh-TW">
                 <a:solidFill>
-                  <a:srgbClr val="FFFFFF"/>
+                  <a:srgbClr val="EEE9DF"/>
                 </a:solidFill>
                 <a:latin typeface="Noto Sans TC"/>
                 <a:ea typeface="Noto Sans TC"/>
@@ -5846,7 +5846,7 @@
             <a:r>
               <a:rPr sz="1400" b="0" lang="zh-TW">
                 <a:solidFill>
-                  <a:srgbClr val="D6D3F0"/>
+                  <a:srgbClr val="C9C1B1"/>
                 </a:solidFill>
                 <a:latin typeface="Noto Sans TC"/>
                 <a:ea typeface="Noto Sans TC"/>
@@ -5874,13 +5874,13 @@
             </a:avLst>
           </a:prstGeom>
           <a:solidFill>
-            <a:srgbClr val="FFFFFF">
+            <a:srgbClr val="EEE9DF">
               <a:alpha val="12000"/>
             </a:srgbClr>
           </a:solidFill>
           <a:ln w="9525">
             <a:solidFill>
-              <a:srgbClr val="FFFFFF">
+              <a:srgbClr val="EEE9DF">
                 <a:alpha val="35000"/>
               </a:srgbClr>
             </a:solidFill>
@@ -5951,7 +5951,7 @@
             <a:r>
               <a:rPr sz="1600" b="1" lang="zh-TW">
                 <a:solidFill>
-                  <a:srgbClr val="FFFFFF"/>
+                  <a:srgbClr val="EEE9DF"/>
                 </a:solidFill>
                 <a:latin typeface="Noto Sans TC"/>
                 <a:ea typeface="Noto Sans TC"/>
@@ -5988,7 +5988,7 @@
             <a:r>
               <a:rPr sz="1400" b="0" lang="zh-TW">
                 <a:solidFill>
-                  <a:srgbClr val="D6D3F0"/>
+                  <a:srgbClr val="C9C1B1"/>
                 </a:solidFill>
                 <a:latin typeface="Noto Sans TC"/>
                 <a:ea typeface="Noto Sans TC"/>
@@ -6016,13 +6016,13 @@
             </a:avLst>
           </a:prstGeom>
           <a:solidFill>
-            <a:srgbClr val="FFFFFF">
+            <a:srgbClr val="EEE9DF">
               <a:alpha val="12000"/>
             </a:srgbClr>
           </a:solidFill>
           <a:ln w="9525">
             <a:solidFill>
-              <a:srgbClr val="FFFFFF">
+              <a:srgbClr val="EEE9DF">
                 <a:alpha val="35000"/>
               </a:srgbClr>
             </a:solidFill>
@@ -6093,7 +6093,7 @@
             <a:r>
               <a:rPr sz="1600" b="1" lang="zh-TW">
                 <a:solidFill>
-                  <a:srgbClr val="FFFFFF"/>
+                  <a:srgbClr val="EEE9DF"/>
                 </a:solidFill>
                 <a:latin typeface="Noto Sans TC"/>
                 <a:ea typeface="Noto Sans TC"/>
@@ -6130,7 +6130,7 @@
             <a:r>
               <a:rPr sz="1400" b="0" lang="zh-TW">
                 <a:solidFill>
-                  <a:srgbClr val="D6D3F0"/>
+                  <a:srgbClr val="C9C1B1"/>
                 </a:solidFill>
                 <a:latin typeface="Noto Sans TC"/>
                 <a:ea typeface="Noto Sans TC"/>
@@ -6158,18 +6158,18 @@
             </a:avLst>
           </a:prstGeom>
           <a:solidFill>
-            <a:srgbClr val="00F2FE">
-              <a:alpha val="20000"/>
+            <a:srgbClr val="2C3B4D">
+              <a:alpha val="85000"/>
             </a:srgbClr>
           </a:solidFill>
           <a:ln w="15875">
             <a:solidFill>
-              <a:srgbClr val="00F2FE"/>
+              <a:srgbClr val="FFB162"/>
             </a:solidFill>
           </a:ln>
           <a:effectLst>
             <a:glow rad="101600">
-              <a:srgbClr val="00F2FE">
+              <a:srgbClr val="FFB162">
                 <a:alpha val="45000"/>
               </a:srgbClr>
             </a:glow>
@@ -6238,7 +6238,7 @@
             <a:r>
               <a:rPr sz="1600" b="1" lang="zh-TW">
                 <a:solidFill>
-                  <a:srgbClr val="FFFFFF"/>
+                  <a:srgbClr val="EEE9DF"/>
                 </a:solidFill>
                 <a:latin typeface="Noto Sans TC"/>
                 <a:ea typeface="Noto Sans TC"/>
@@ -6275,7 +6275,7 @@
             <a:r>
               <a:rPr sz="1400" b="0" lang="zh-TW">
                 <a:solidFill>
-                  <a:srgbClr val="D6D3F0"/>
+                  <a:srgbClr val="C9C1B1"/>
                 </a:solidFill>
                 <a:latin typeface="Noto Sans TC"/>
                 <a:ea typeface="Noto Sans TC"/>
@@ -6312,7 +6312,7 @@
             <a:r>
               <a:rPr sz="1400" b="0" lang="zh-TW">
                 <a:solidFill>
-                  <a:srgbClr val="D6D3F0"/>
+                  <a:srgbClr val="C9C1B1"/>
                 </a:solidFill>
                 <a:latin typeface="Noto Sans TC"/>
                 <a:ea typeface="Noto Sans TC"/>
@@ -8099,10 +8099,10 @@
         <a:gradFill rotWithShape="1">
           <a:gsLst>
             <a:gs pos="0">
-              <a:srgbClr val="1F1C5C"/>
+              <a:srgbClr val="1B2632"/>
             </a:gs>
             <a:gs pos="100000">
-              <a:srgbClr val="5B1F6E"/>
+              <a:srgbClr val="2C3B4D"/>
             </a:gs>
           </a:gsLst>
           <a:lin scaled="0" ang="2700000"/>
@@ -8119,7 +8119,7 @@
       <p:grpSpPr/>
       <p:sp>
         <p:nvSpPr>
-          <p:cNvPr id="2" name="!!orb-violet"/>
+          <p:cNvPr id="2" name="!!orb-orange"/>
           <p:cNvSpPr/>
           <p:nvPr/>
         </p:nvSpPr>
@@ -8132,8 +8132,8 @@
             <a:avLst/>
           </a:prstGeom>
           <a:solidFill>
-            <a:srgbClr val="667EEA">
-              <a:alpha val="55000"/>
+            <a:srgbClr val="FFB162">
+              <a:alpha val="35000"/>
             </a:srgbClr>
           </a:solidFill>
           <a:ln>
@@ -8153,7 +8153,7 @@
       </p:sp>
       <p:sp>
         <p:nvSpPr>
-          <p:cNvPr id="3" name="!!orb-pink"/>
+          <p:cNvPr id="3" name="!!orb-rust"/>
           <p:cNvSpPr/>
           <p:nvPr/>
         </p:nvSpPr>
@@ -8166,8 +8166,8 @@
             <a:avLst/>
           </a:prstGeom>
           <a:solidFill>
-            <a:srgbClr val="F093FB">
-              <a:alpha val="45000"/>
+            <a:srgbClr val="A35139">
+              <a:alpha val="55000"/>
             </a:srgbClr>
           </a:solidFill>
           <a:ln>
@@ -8187,7 +8187,7 @@
       </p:sp>
       <p:sp>
         <p:nvSpPr>
-          <p:cNvPr id="4" name="!!orb-cyan"/>
+          <p:cNvPr id="4" name="!!orb-cream"/>
           <p:cNvSpPr/>
           <p:nvPr/>
         </p:nvSpPr>
@@ -8200,8 +8200,8 @@
             <a:avLst/>
           </a:prstGeom>
           <a:solidFill>
-            <a:srgbClr val="00F2FE">
-              <a:alpha val="30000"/>
+            <a:srgbClr val="EEE9DF">
+              <a:alpha val="12000"/>
             </a:srgbClr>
           </a:solidFill>
           <a:ln>
@@ -8245,7 +8245,7 @@
             <a:r>
               <a:rPr sz="2600" b="1" lang="zh-TW">
                 <a:solidFill>
-                  <a:srgbClr val="FFFFFF"/>
+                  <a:srgbClr val="EEE9DF"/>
                 </a:solidFill>
                 <a:effectLst>
                   <a:outerShdw blurRad="50800" dist="19050" dir="5400000" algn="ctr" rotWithShape="0">
@@ -8289,7 +8289,7 @@
             <a:r>
               <a:rPr sz="1050" b="0" lang="zh-TW">
                 <a:solidFill>
-                  <a:srgbClr val="D6D3F0"/>
+                  <a:srgbClr val="C9C1B1"/>
                 </a:solidFill>
                 <a:latin typeface="Noto Sans TC"/>
                 <a:ea typeface="Noto Sans TC"/>
@@ -8326,7 +8326,7 @@
             <a:r>
               <a:rPr sz="1050" b="0" lang="zh-TW">
                 <a:solidFill>
-                  <a:srgbClr val="D6D3F0"/>
+                  <a:srgbClr val="C9C1B1"/>
                 </a:solidFill>
                 <a:latin typeface="Noto Sans TC"/>
                 <a:ea typeface="Noto Sans TC"/>
@@ -8363,7 +8363,7 @@
             <a:r>
               <a:rPr sz="1050" b="1" lang="zh-TW">
                 <a:solidFill>
-                  <a:srgbClr val="D6D3F0"/>
+                  <a:srgbClr val="C9C1B1"/>
                 </a:solidFill>
                 <a:latin typeface="Noto Sans TC"/>
                 <a:ea typeface="Noto Sans TC"/>
@@ -8400,7 +8400,7 @@
             <a:r>
               <a:rPr sz="1050" b="1" lang="zh-TW">
                 <a:solidFill>
-                  <a:srgbClr val="00F2FE"/>
+                  <a:srgbClr val="FFB162"/>
                 </a:solidFill>
                 <a:latin typeface="Noto Sans TC"/>
                 <a:ea typeface="Noto Sans TC"/>
@@ -8437,7 +8437,7 @@
             <a:r>
               <a:rPr sz="1050" b="1" lang="zh-TW">
                 <a:solidFill>
-                  <a:srgbClr val="D6D3F0"/>
+                  <a:srgbClr val="C9C1B1"/>
                 </a:solidFill>
                 <a:latin typeface="Noto Sans TC"/>
                 <a:ea typeface="Noto Sans TC"/>
@@ -8465,13 +8465,13 @@
             </a:avLst>
           </a:prstGeom>
           <a:solidFill>
-            <a:srgbClr val="FFFFFF">
+            <a:srgbClr val="EEE9DF">
               <a:alpha val="12000"/>
             </a:srgbClr>
           </a:solidFill>
           <a:ln w="9525">
             <a:solidFill>
-              <a:srgbClr val="FFFFFF">
+              <a:srgbClr val="EEE9DF">
                 <a:alpha val="35000"/>
               </a:srgbClr>
             </a:solidFill>
@@ -8518,7 +8518,7 @@
             <a:r>
               <a:rPr sz="1600" b="1" lang="zh-TW">
                 <a:solidFill>
-                  <a:srgbClr val="FFFFFF"/>
+                  <a:srgbClr val="EEE9DF"/>
                 </a:solidFill>
                 <a:latin typeface="Noto Sans TC"/>
                 <a:ea typeface="Noto Sans TC"/>
@@ -8555,7 +8555,7 @@
             <a:r>
               <a:rPr sz="1400" b="0" lang="zh-TW">
                 <a:solidFill>
-                  <a:srgbClr val="FFFFFF"/>
+                  <a:srgbClr val="EEE9DF"/>
                 </a:solidFill>
                 <a:latin typeface="Noto Sans TC"/>
                 <a:ea typeface="Noto Sans TC"/>
@@ -8592,7 +8592,7 @@
             <a:r>
               <a:rPr sz="1400" b="0" lang="zh-TW">
                 <a:solidFill>
-                  <a:srgbClr val="D6D3F0"/>
+                  <a:srgbClr val="C9C1B1"/>
                 </a:solidFill>
                 <a:latin typeface="Noto Sans TC"/>
                 <a:ea typeface="Noto Sans TC"/>
@@ -8620,13 +8620,13 @@
             </a:avLst>
           </a:prstGeom>
           <a:solidFill>
-            <a:srgbClr val="FFFFFF">
+            <a:srgbClr val="EEE9DF">
               <a:alpha val="12000"/>
             </a:srgbClr>
           </a:solidFill>
           <a:ln w="9525">
             <a:solidFill>
-              <a:srgbClr val="FFFFFF">
+              <a:srgbClr val="EEE9DF">
                 <a:alpha val="35000"/>
               </a:srgbClr>
             </a:solidFill>
@@ -8673,7 +8673,7 @@
             <a:r>
               <a:rPr sz="1600" b="1" lang="zh-TW">
                 <a:solidFill>
-                  <a:srgbClr val="FFFFFF"/>
+                  <a:srgbClr val="EEE9DF"/>
                 </a:solidFill>
                 <a:latin typeface="Noto Sans TC"/>
                 <a:ea typeface="Noto Sans TC"/>
@@ -8710,7 +8710,7 @@
             <a:r>
               <a:rPr sz="1400" b="0" lang="zh-TW">
                 <a:solidFill>
-                  <a:srgbClr val="FFFFFF"/>
+                  <a:srgbClr val="EEE9DF"/>
                 </a:solidFill>
                 <a:latin typeface="Noto Sans TC"/>
                 <a:ea typeface="Noto Sans TC"/>
@@ -8747,7 +8747,7 @@
             <a:r>
               <a:rPr sz="1400" b="0" lang="zh-TW">
                 <a:solidFill>
-                  <a:srgbClr val="D6D3F0"/>
+                  <a:srgbClr val="C9C1B1"/>
                 </a:solidFill>
                 <a:latin typeface="Noto Sans TC"/>
                 <a:ea typeface="Noto Sans TC"/>
@@ -8775,13 +8775,13 @@
             </a:avLst>
           </a:prstGeom>
           <a:solidFill>
-            <a:srgbClr val="FFFFFF">
+            <a:srgbClr val="EEE9DF">
               <a:alpha val="12000"/>
             </a:srgbClr>
           </a:solidFill>
           <a:ln w="9525">
             <a:solidFill>
-              <a:srgbClr val="FFFFFF">
+              <a:srgbClr val="EEE9DF">
                 <a:alpha val="35000"/>
               </a:srgbClr>
             </a:solidFill>
@@ -8828,7 +8828,7 @@
             <a:r>
               <a:rPr sz="1600" b="1" lang="zh-TW">
                 <a:solidFill>
-                  <a:srgbClr val="FFFFFF"/>
+                  <a:srgbClr val="EEE9DF"/>
                 </a:solidFill>
                 <a:latin typeface="Noto Sans TC"/>
                 <a:ea typeface="Noto Sans TC"/>
@@ -8865,7 +8865,7 @@
             <a:r>
               <a:rPr sz="1400" b="0" lang="zh-TW">
                 <a:solidFill>
-                  <a:srgbClr val="FFFFFF"/>
+                  <a:srgbClr val="EEE9DF"/>
                 </a:solidFill>
                 <a:latin typeface="Noto Sans TC"/>
                 <a:ea typeface="Noto Sans TC"/>
@@ -8902,7 +8902,7 @@
             <a:r>
               <a:rPr sz="1400" b="0" lang="zh-TW">
                 <a:solidFill>
-                  <a:srgbClr val="D6D3F0"/>
+                  <a:srgbClr val="C9C1B1"/>
                 </a:solidFill>
                 <a:latin typeface="Noto Sans TC"/>
                 <a:ea typeface="Noto Sans TC"/>
@@ -8930,13 +8930,13 @@
             </a:avLst>
           </a:prstGeom>
           <a:solidFill>
-            <a:srgbClr val="FFFFFF">
+            <a:srgbClr val="EEE9DF">
               <a:alpha val="12000"/>
             </a:srgbClr>
           </a:solidFill>
           <a:ln w="9525">
             <a:solidFill>
-              <a:srgbClr val="FFFFFF">
+              <a:srgbClr val="EEE9DF">
                 <a:alpha val="35000"/>
               </a:srgbClr>
             </a:solidFill>
@@ -8983,7 +8983,7 @@
             <a:r>
               <a:rPr sz="1600" b="1" lang="zh-TW">
                 <a:solidFill>
-                  <a:srgbClr val="FFFFFF"/>
+                  <a:srgbClr val="EEE9DF"/>
                 </a:solidFill>
                 <a:latin typeface="Noto Sans TC"/>
                 <a:ea typeface="Noto Sans TC"/>
@@ -9020,7 +9020,7 @@
             <a:r>
               <a:rPr sz="1400" b="0" lang="zh-TW">
                 <a:solidFill>
-                  <a:srgbClr val="FFFFFF"/>
+                  <a:srgbClr val="EEE9DF"/>
                 </a:solidFill>
                 <a:latin typeface="Noto Sans TC"/>
                 <a:ea typeface="Noto Sans TC"/>
@@ -9057,7 +9057,7 @@
             <a:r>
               <a:rPr sz="1400" b="0" lang="zh-TW">
                 <a:solidFill>
-                  <a:srgbClr val="D6D3F0"/>
+                  <a:srgbClr val="C9C1B1"/>
                 </a:solidFill>
                 <a:latin typeface="Noto Sans TC"/>
                 <a:ea typeface="Noto Sans TC"/>
@@ -10375,10 +10375,10 @@
         <a:gradFill rotWithShape="1">
           <a:gsLst>
             <a:gs pos="0">
-              <a:srgbClr val="1F1C5C"/>
+              <a:srgbClr val="1B2632"/>
             </a:gs>
             <a:gs pos="100000">
-              <a:srgbClr val="5B1F6E"/>
+              <a:srgbClr val="2C3B4D"/>
             </a:gs>
           </a:gsLst>
           <a:lin scaled="0" ang="2700000"/>
@@ -10395,7 +10395,7 @@
       <p:grpSpPr/>
       <p:sp>
         <p:nvSpPr>
-          <p:cNvPr id="2" name="!!orb-violet"/>
+          <p:cNvPr id="2" name="!!orb-orange"/>
           <p:cNvSpPr/>
           <p:nvPr/>
         </p:nvSpPr>
@@ -10408,8 +10408,8 @@
             <a:avLst/>
           </a:prstGeom>
           <a:solidFill>
-            <a:srgbClr val="667EEA">
-              <a:alpha val="55000"/>
+            <a:srgbClr val="FFB162">
+              <a:alpha val="35000"/>
             </a:srgbClr>
           </a:solidFill>
           <a:ln>
@@ -10429,7 +10429,7 @@
       </p:sp>
       <p:sp>
         <p:nvSpPr>
-          <p:cNvPr id="3" name="!!orb-pink"/>
+          <p:cNvPr id="3" name="!!orb-rust"/>
           <p:cNvSpPr/>
           <p:nvPr/>
         </p:nvSpPr>
@@ -10442,8 +10442,8 @@
             <a:avLst/>
           </a:prstGeom>
           <a:solidFill>
-            <a:srgbClr val="F093FB">
-              <a:alpha val="45000"/>
+            <a:srgbClr val="A35139">
+              <a:alpha val="55000"/>
             </a:srgbClr>
           </a:solidFill>
           <a:ln>
@@ -10463,7 +10463,7 @@
       </p:sp>
       <p:sp>
         <p:nvSpPr>
-          <p:cNvPr id="4" name="!!orb-cyan"/>
+          <p:cNvPr id="4" name="!!orb-cream"/>
           <p:cNvSpPr/>
           <p:nvPr/>
         </p:nvSpPr>
@@ -10476,8 +10476,8 @@
             <a:avLst/>
           </a:prstGeom>
           <a:solidFill>
-            <a:srgbClr val="00F2FE">
-              <a:alpha val="30000"/>
+            <a:srgbClr val="EEE9DF">
+              <a:alpha val="12000"/>
             </a:srgbClr>
           </a:solidFill>
           <a:ln>
@@ -10521,7 +10521,7 @@
             <a:r>
               <a:rPr sz="2600" b="1" lang="zh-TW">
                 <a:solidFill>
-                  <a:srgbClr val="FFFFFF"/>
+                  <a:srgbClr val="EEE9DF"/>
                 </a:solidFill>
                 <a:effectLst>
                   <a:outerShdw blurRad="50800" dist="19050" dir="5400000" algn="ctr" rotWithShape="0">
@@ -10565,7 +10565,7 @@
             <a:r>
               <a:rPr sz="1050" b="0" lang="zh-TW">
                 <a:solidFill>
-                  <a:srgbClr val="D6D3F0"/>
+                  <a:srgbClr val="C9C1B1"/>
                 </a:solidFill>
                 <a:latin typeface="Noto Sans TC"/>
                 <a:ea typeface="Noto Sans TC"/>
@@ -10602,7 +10602,7 @@
             <a:r>
               <a:rPr sz="1050" b="0" lang="zh-TW">
                 <a:solidFill>
-                  <a:srgbClr val="D6D3F0"/>
+                  <a:srgbClr val="C9C1B1"/>
                 </a:solidFill>
                 <a:latin typeface="Noto Sans TC"/>
                 <a:ea typeface="Noto Sans TC"/>
@@ -10632,13 +10632,13 @@
             </a:avLst>
           </a:prstGeom>
           <a:solidFill>
-            <a:srgbClr val="FFFFFF">
+            <a:srgbClr val="EEE9DF">
               <a:alpha val="12000"/>
             </a:srgbClr>
           </a:solidFill>
           <a:ln w="9525">
             <a:solidFill>
-              <a:srgbClr val="FFFFFF">
+              <a:srgbClr val="EEE9DF">
                 <a:alpha val="35000"/>
               </a:srgbClr>
             </a:solidFill>
@@ -10661,7 +10661,7 @@
             <a:r>
               <a:rPr sz="1050" b="0" lang="zh-TW">
                 <a:solidFill>
-                  <a:srgbClr val="00F2FE"/>
+                  <a:srgbClr val="FFB162"/>
                 </a:solidFill>
                 <a:latin typeface="Noto Sans TC"/>
                 <a:ea typeface="Noto Sans TC"/>
@@ -10675,7 +10675,7 @@
             <a:r>
               <a:rPr sz="1600" b="1" lang="zh-TW">
                 <a:solidFill>
-                  <a:srgbClr val="FFFFFF"/>
+                  <a:srgbClr val="EEE9DF"/>
                 </a:solidFill>
                 <a:latin typeface="Noto Sans TC"/>
                 <a:ea typeface="Noto Sans TC"/>
@@ -10703,7 +10703,7 @@
           <a:noFill/>
           <a:ln w="15875">
             <a:solidFill>
-              <a:srgbClr val="00F2FE"/>
+              <a:srgbClr val="FFB162"/>
             </a:solidFill>
           </a:ln>
         </p:spPr>
@@ -10717,7 +10717,7 @@
             <a:r>
               <a:rPr sz="1600" b="1" lang="zh-TW">
                 <a:solidFill>
-                  <a:srgbClr val="00F2FE"/>
+                  <a:srgbClr val="FFB162"/>
                 </a:solidFill>
                 <a:latin typeface="Noto Sans TC"/>
                 <a:ea typeface="Noto Sans TC"/>
@@ -10754,7 +10754,7 @@
             <a:r>
               <a:rPr sz="1400" b="0" lang="zh-TW">
                 <a:solidFill>
-                  <a:srgbClr val="FFFFFF"/>
+                  <a:srgbClr val="EEE9DF"/>
                 </a:solidFill>
                 <a:latin typeface="Noto Sans TC"/>
                 <a:ea typeface="Noto Sans TC"/>
@@ -10784,13 +10784,13 @@
             </a:avLst>
           </a:prstGeom>
           <a:solidFill>
-            <a:srgbClr val="FFFFFF">
+            <a:srgbClr val="EEE9DF">
               <a:alpha val="12000"/>
             </a:srgbClr>
           </a:solidFill>
           <a:ln w="9525">
             <a:solidFill>
-              <a:srgbClr val="FFFFFF">
+              <a:srgbClr val="EEE9DF">
                 <a:alpha val="35000"/>
               </a:srgbClr>
             </a:solidFill>
@@ -10813,7 +10813,7 @@
             <a:r>
               <a:rPr sz="1050" b="0" lang="zh-TW">
                 <a:solidFill>
-                  <a:srgbClr val="00F2FE"/>
+                  <a:srgbClr val="FFB162"/>
                 </a:solidFill>
                 <a:latin typeface="Noto Sans TC"/>
                 <a:ea typeface="Noto Sans TC"/>
@@ -10827,7 +10827,7 @@
             <a:r>
               <a:rPr sz="1600" b="1" lang="zh-TW">
                 <a:solidFill>
-                  <a:srgbClr val="FFFFFF"/>
+                  <a:srgbClr val="EEE9DF"/>
                 </a:solidFill>
                 <a:latin typeface="Noto Sans TC"/>
                 <a:ea typeface="Noto Sans TC"/>
@@ -10855,7 +10855,7 @@
           <a:noFill/>
           <a:ln w="15875">
             <a:solidFill>
-              <a:srgbClr val="00F2FE"/>
+              <a:srgbClr val="FFB162"/>
             </a:solidFill>
           </a:ln>
         </p:spPr>
@@ -10869,7 +10869,7 @@
             <a:r>
               <a:rPr sz="1600" b="1" lang="zh-TW">
                 <a:solidFill>
-                  <a:srgbClr val="00F2FE"/>
+                  <a:srgbClr val="FFB162"/>
                 </a:solidFill>
                 <a:latin typeface="Noto Sans TC"/>
                 <a:ea typeface="Noto Sans TC"/>
@@ -10906,7 +10906,7 @@
             <a:r>
               <a:rPr sz="1400" b="0" lang="zh-TW">
                 <a:solidFill>
-                  <a:srgbClr val="FFFFFF"/>
+                  <a:srgbClr val="EEE9DF"/>
                 </a:solidFill>
                 <a:latin typeface="Noto Sans TC"/>
                 <a:ea typeface="Noto Sans TC"/>
@@ -10936,13 +10936,13 @@
             </a:avLst>
           </a:prstGeom>
           <a:solidFill>
-            <a:srgbClr val="FFFFFF">
+            <a:srgbClr val="EEE9DF">
               <a:alpha val="12000"/>
             </a:srgbClr>
           </a:solidFill>
           <a:ln w="9525">
             <a:solidFill>
-              <a:srgbClr val="FFFFFF">
+              <a:srgbClr val="EEE9DF">
                 <a:alpha val="35000"/>
               </a:srgbClr>
             </a:solidFill>
@@ -10965,7 +10965,7 @@
             <a:r>
               <a:rPr sz="1050" b="0" lang="zh-TW">
                 <a:solidFill>
-                  <a:srgbClr val="00F2FE"/>
+                  <a:srgbClr val="FFB162"/>
                 </a:solidFill>
                 <a:latin typeface="Noto Sans TC"/>
                 <a:ea typeface="Noto Sans TC"/>
@@ -10979,7 +10979,7 @@
             <a:r>
               <a:rPr sz="1600" b="1" lang="zh-TW">
                 <a:solidFill>
-                  <a:srgbClr val="FFFFFF"/>
+                  <a:srgbClr val="EEE9DF"/>
                 </a:solidFill>
                 <a:latin typeface="Noto Sans TC"/>
                 <a:ea typeface="Noto Sans TC"/>
@@ -11007,7 +11007,7 @@
           <a:noFill/>
           <a:ln w="15875">
             <a:solidFill>
-              <a:srgbClr val="00F2FE"/>
+              <a:srgbClr val="FFB162"/>
             </a:solidFill>
           </a:ln>
         </p:spPr>
@@ -11021,7 +11021,7 @@
             <a:r>
               <a:rPr sz="1600" b="1" lang="zh-TW">
                 <a:solidFill>
-                  <a:srgbClr val="00F2FE"/>
+                  <a:srgbClr val="FFB162"/>
                 </a:solidFill>
                 <a:latin typeface="Noto Sans TC"/>
                 <a:ea typeface="Noto Sans TC"/>
@@ -11058,7 +11058,7 @@
             <a:r>
               <a:rPr sz="1400" b="0" lang="zh-TW">
                 <a:solidFill>
-                  <a:srgbClr val="FFFFFF"/>
+                  <a:srgbClr val="EEE9DF"/>
                 </a:solidFill>
                 <a:latin typeface="Noto Sans TC"/>
                 <a:ea typeface="Noto Sans TC"/>
@@ -11921,10 +11921,10 @@
         <a:gradFill rotWithShape="1">
           <a:gsLst>
             <a:gs pos="0">
-              <a:srgbClr val="1F1C5C"/>
+              <a:srgbClr val="1B2632"/>
             </a:gs>
             <a:gs pos="100000">
-              <a:srgbClr val="5B1F6E"/>
+              <a:srgbClr val="2C3B4D"/>
             </a:gs>
           </a:gsLst>
           <a:lin scaled="0" ang="2700000"/>
@@ -11941,7 +11941,7 @@
       <p:grpSpPr/>
       <p:sp>
         <p:nvSpPr>
-          <p:cNvPr id="2" name="!!orb-violet"/>
+          <p:cNvPr id="2" name="!!orb-orange"/>
           <p:cNvSpPr/>
           <p:nvPr/>
         </p:nvSpPr>
@@ -11954,8 +11954,8 @@
             <a:avLst/>
           </a:prstGeom>
           <a:solidFill>
-            <a:srgbClr val="667EEA">
-              <a:alpha val="55000"/>
+            <a:srgbClr val="FFB162">
+              <a:alpha val="35000"/>
             </a:srgbClr>
           </a:solidFill>
           <a:ln>
@@ -11975,7 +11975,7 @@
       </p:sp>
       <p:sp>
         <p:nvSpPr>
-          <p:cNvPr id="3" name="!!orb-pink"/>
+          <p:cNvPr id="3" name="!!orb-rust"/>
           <p:cNvSpPr/>
           <p:nvPr/>
         </p:nvSpPr>
@@ -11988,8 +11988,8 @@
             <a:avLst/>
           </a:prstGeom>
           <a:solidFill>
-            <a:srgbClr val="F093FB">
-              <a:alpha val="45000"/>
+            <a:srgbClr val="A35139">
+              <a:alpha val="55000"/>
             </a:srgbClr>
           </a:solidFill>
           <a:ln>
@@ -12009,7 +12009,7 @@
       </p:sp>
       <p:sp>
         <p:nvSpPr>
-          <p:cNvPr id="4" name="!!orb-cyan"/>
+          <p:cNvPr id="4" name="!!orb-cream"/>
           <p:cNvSpPr/>
           <p:nvPr/>
         </p:nvSpPr>
@@ -12022,8 +12022,8 @@
             <a:avLst/>
           </a:prstGeom>
           <a:solidFill>
-            <a:srgbClr val="00F2FE">
-              <a:alpha val="30000"/>
+            <a:srgbClr val="EEE9DF">
+              <a:alpha val="12000"/>
             </a:srgbClr>
           </a:solidFill>
           <a:ln>
@@ -12067,7 +12067,7 @@
             <a:r>
               <a:rPr sz="2600" b="1" lang="zh-TW">
                 <a:solidFill>
-                  <a:srgbClr val="FFFFFF"/>
+                  <a:srgbClr val="EEE9DF"/>
                 </a:solidFill>
                 <a:effectLst>
                   <a:outerShdw blurRad="50800" dist="19050" dir="5400000" algn="ctr" rotWithShape="0">
@@ -12111,7 +12111,7 @@
             <a:r>
               <a:rPr sz="1050" b="0" lang="zh-TW">
                 <a:solidFill>
-                  <a:srgbClr val="D6D3F0"/>
+                  <a:srgbClr val="C9C1B1"/>
                 </a:solidFill>
                 <a:latin typeface="Noto Sans TC"/>
                 <a:ea typeface="Noto Sans TC"/>
@@ -12148,7 +12148,7 @@
             <a:r>
               <a:rPr sz="1050" b="0" lang="zh-TW">
                 <a:solidFill>
-                  <a:srgbClr val="D6D3F0"/>
+                  <a:srgbClr val="C9C1B1"/>
                 </a:solidFill>
                 <a:latin typeface="Noto Sans TC"/>
                 <a:ea typeface="Noto Sans TC"/>
@@ -12176,13 +12176,13 @@
             </a:avLst>
           </a:prstGeom>
           <a:solidFill>
-            <a:srgbClr val="FFFFFF">
+            <a:srgbClr val="EEE9DF">
               <a:alpha val="12000"/>
             </a:srgbClr>
           </a:solidFill>
           <a:ln w="9525">
             <a:solidFill>
-              <a:srgbClr val="FFFFFF">
+              <a:srgbClr val="EEE9DF">
                 <a:alpha val="35000"/>
               </a:srgbClr>
             </a:solidFill>
@@ -12229,7 +12229,7 @@
             <a:r>
               <a:rPr sz="1600" b="1" lang="zh-TW">
                 <a:solidFill>
-                  <a:srgbClr val="00F2FE"/>
+                  <a:srgbClr val="FFB162"/>
                 </a:solidFill>
                 <a:latin typeface="Noto Sans TC"/>
                 <a:ea typeface="Noto Sans TC"/>
@@ -12266,7 +12266,7 @@
             <a:r>
               <a:rPr sz="1600" b="1" lang="zh-TW">
                 <a:solidFill>
-                  <a:srgbClr val="FFFFFF"/>
+                  <a:srgbClr val="EEE9DF"/>
                 </a:solidFill>
                 <a:latin typeface="Noto Sans TC"/>
                 <a:ea typeface="Noto Sans TC"/>
@@ -12307,7 +12307,7 @@
             <a:r>
               <a:rPr sz="1400" b="0" lang="zh-TW">
                 <a:solidFill>
-                  <a:srgbClr val="D6D3F0"/>
+                  <a:srgbClr val="C9C1B1"/>
                 </a:solidFill>
                 <a:latin typeface="Noto Sans TC"/>
                 <a:ea typeface="Noto Sans TC"/>
@@ -12335,13 +12335,13 @@
             </a:avLst>
           </a:prstGeom>
           <a:solidFill>
-            <a:srgbClr val="FFFFFF">
+            <a:srgbClr val="EEE9DF">
               <a:alpha val="12000"/>
             </a:srgbClr>
           </a:solidFill>
           <a:ln w="9525">
             <a:solidFill>
-              <a:srgbClr val="FFFFFF">
+              <a:srgbClr val="EEE9DF">
                 <a:alpha val="35000"/>
               </a:srgbClr>
             </a:solidFill>
@@ -12388,7 +12388,7 @@
             <a:r>
               <a:rPr sz="1600" b="1" lang="zh-TW">
                 <a:solidFill>
-                  <a:srgbClr val="00F2FE"/>
+                  <a:srgbClr val="FFB162"/>
                 </a:solidFill>
                 <a:latin typeface="Noto Sans TC"/>
                 <a:ea typeface="Noto Sans TC"/>
@@ -12425,7 +12425,7 @@
             <a:r>
               <a:rPr sz="1600" b="1" lang="zh-TW">
                 <a:solidFill>
-                  <a:srgbClr val="FFFFFF"/>
+                  <a:srgbClr val="EEE9DF"/>
                 </a:solidFill>
                 <a:latin typeface="Noto Sans TC"/>
                 <a:ea typeface="Noto Sans TC"/>
@@ -12466,7 +12466,7 @@
             <a:r>
               <a:rPr sz="1400" b="0" lang="zh-TW">
                 <a:solidFill>
-                  <a:srgbClr val="D6D3F0"/>
+                  <a:srgbClr val="C9C1B1"/>
                 </a:solidFill>
                 <a:latin typeface="Noto Sans TC"/>
                 <a:ea typeface="Noto Sans TC"/>
@@ -12494,18 +12494,18 @@
             </a:avLst>
           </a:prstGeom>
           <a:solidFill>
-            <a:srgbClr val="00F2FE">
-              <a:alpha val="20000"/>
+            <a:srgbClr val="2C3B4D">
+              <a:alpha val="85000"/>
             </a:srgbClr>
           </a:solidFill>
           <a:ln w="15875">
             <a:solidFill>
-              <a:srgbClr val="00F2FE"/>
+              <a:srgbClr val="FFB162"/>
             </a:solidFill>
           </a:ln>
           <a:effectLst>
             <a:glow rad="101600">
-              <a:srgbClr val="00F2FE">
+              <a:srgbClr val="FFB162">
                 <a:alpha val="45000"/>
               </a:srgbClr>
             </a:glow>
@@ -12550,7 +12550,7 @@
             <a:r>
               <a:rPr sz="1600" b="1" lang="zh-TW">
                 <a:solidFill>
-                  <a:srgbClr val="00F2FE"/>
+                  <a:srgbClr val="FFB162"/>
                 </a:solidFill>
                 <a:latin typeface="Noto Sans TC"/>
                 <a:ea typeface="Noto Sans TC"/>
@@ -12587,7 +12587,7 @@
             <a:r>
               <a:rPr sz="1600" b="1" lang="zh-TW">
                 <a:solidFill>
-                  <a:srgbClr val="FFFFFF"/>
+                  <a:srgbClr val="EEE9DF"/>
                 </a:solidFill>
                 <a:latin typeface="Noto Sans TC"/>
                 <a:ea typeface="Noto Sans TC"/>
@@ -12628,7 +12628,7 @@
             <a:r>
               <a:rPr sz="1400" b="0" lang="zh-TW">
                 <a:solidFill>
-                  <a:srgbClr val="D6D3F0"/>
+                  <a:srgbClr val="C9C1B1"/>
                 </a:solidFill>
                 <a:latin typeface="Noto Sans TC"/>
                 <a:ea typeface="Noto Sans TC"/>
@@ -13605,7 +13605,7 @@
                                   <p:childTnLst>
                                     <p:animRot by="120000">
                                       <p:cBhvr>
-                                        <p:cTn id="59" dur="50" fill="hold">
+                                        <p:cTn id="59" dur="40" fill="hold">
                                           <p:stCondLst>
                                             <p:cond delay="0"/>
                                           </p:stCondLst>
@@ -13620,9 +13620,9 @@
                                     </p:animRot>
                                     <p:animRot by="-240000">
                                       <p:cBhvr>
-                                        <p:cTn id="60" dur="100" fill="hold">
+                                        <p:cTn id="60" dur="80" fill="hold">
                                           <p:stCondLst>
-                                            <p:cond delay="50"/>
+                                            <p:cond delay="80"/>
                                           </p:stCondLst>
                                         </p:cTn>
                                         <p:tgtEl>
@@ -13635,9 +13635,9 @@
                                     </p:animRot>
                                     <p:animRot by="240000">
                                       <p:cBhvr>
-                                        <p:cTn id="61" dur="100" fill="hold">
+                                        <p:cTn id="61" dur="80" fill="hold">
                                           <p:stCondLst>
-                                            <p:cond delay="150"/>
+                                            <p:cond delay="160"/>
                                           </p:stCondLst>
                                         </p:cTn>
                                         <p:tgtEl>
@@ -13650,9 +13650,9 @@
                                     </p:animRot>
                                     <p:animRot by="-240000">
                                       <p:cBhvr>
-                                        <p:cTn id="62" dur="100" fill="hold">
+                                        <p:cTn id="62" dur="80" fill="hold">
                                           <p:stCondLst>
-                                            <p:cond delay="250"/>
+                                            <p:cond delay="240"/>
                                           </p:stCondLst>
                                         </p:cTn>
                                         <p:tgtEl>
@@ -13665,9 +13665,9 @@
                                     </p:animRot>
                                     <p:animRot by="120000">
                                       <p:cBhvr>
-                                        <p:cTn id="63" dur="50" fill="hold">
+                                        <p:cTn id="63" dur="80" fill="hold">
                                           <p:stCondLst>
-                                            <p:cond delay="350"/>
+                                            <p:cond delay="320"/>
                                           </p:stCondLst>
                                         </p:cTn>
                                         <p:tgtEl>
@@ -13735,10 +13735,10 @@
         <a:gradFill rotWithShape="1">
           <a:gsLst>
             <a:gs pos="0">
-              <a:srgbClr val="1F1C5C"/>
+              <a:srgbClr val="1B2632"/>
             </a:gs>
             <a:gs pos="100000">
-              <a:srgbClr val="5B1F6E"/>
+              <a:srgbClr val="2C3B4D"/>
             </a:gs>
           </a:gsLst>
           <a:lin scaled="0" ang="2700000"/>
@@ -13755,7 +13755,7 @@
       <p:grpSpPr/>
       <p:sp>
         <p:nvSpPr>
-          <p:cNvPr id="2" name="!!orb-violet"/>
+          <p:cNvPr id="2" name="!!orb-orange"/>
           <p:cNvSpPr/>
           <p:nvPr/>
         </p:nvSpPr>
@@ -13768,8 +13768,8 @@
             <a:avLst/>
           </a:prstGeom>
           <a:solidFill>
-            <a:srgbClr val="667EEA">
-              <a:alpha val="55000"/>
+            <a:srgbClr val="FFB162">
+              <a:alpha val="35000"/>
             </a:srgbClr>
           </a:solidFill>
           <a:ln>
@@ -13789,7 +13789,7 @@
       </p:sp>
       <p:sp>
         <p:nvSpPr>
-          <p:cNvPr id="3" name="!!orb-pink"/>
+          <p:cNvPr id="3" name="!!orb-rust"/>
           <p:cNvSpPr/>
           <p:nvPr/>
         </p:nvSpPr>
@@ -13802,8 +13802,8 @@
             <a:avLst/>
           </a:prstGeom>
           <a:solidFill>
-            <a:srgbClr val="F093FB">
-              <a:alpha val="45000"/>
+            <a:srgbClr val="A35139">
+              <a:alpha val="55000"/>
             </a:srgbClr>
           </a:solidFill>
           <a:ln>
@@ -13823,7 +13823,7 @@
       </p:sp>
       <p:sp>
         <p:nvSpPr>
-          <p:cNvPr id="4" name="!!orb-cyan"/>
+          <p:cNvPr id="4" name="!!orb-cream"/>
           <p:cNvSpPr/>
           <p:nvPr/>
         </p:nvSpPr>
@@ -13836,8 +13836,8 @@
             <a:avLst/>
           </a:prstGeom>
           <a:solidFill>
-            <a:srgbClr val="00F2FE">
-              <a:alpha val="30000"/>
+            <a:srgbClr val="EEE9DF">
+              <a:alpha val="12000"/>
             </a:srgbClr>
           </a:solidFill>
           <a:ln>
@@ -13881,7 +13881,7 @@
             <a:r>
               <a:rPr sz="2600" b="1" lang="zh-TW">
                 <a:solidFill>
-                  <a:srgbClr val="FFFFFF"/>
+                  <a:srgbClr val="EEE9DF"/>
                 </a:solidFill>
                 <a:effectLst>
                   <a:outerShdw blurRad="50800" dist="19050" dir="5400000" algn="ctr" rotWithShape="0">
@@ -13925,7 +13925,7 @@
             <a:r>
               <a:rPr sz="1050" b="0" lang="zh-TW">
                 <a:solidFill>
-                  <a:srgbClr val="D6D3F0"/>
+                  <a:srgbClr val="C9C1B1"/>
                 </a:solidFill>
                 <a:latin typeface="Noto Sans TC"/>
                 <a:ea typeface="Noto Sans TC"/>
@@ -13962,7 +13962,7 @@
             <a:r>
               <a:rPr sz="1050" b="0" lang="zh-TW">
                 <a:solidFill>
-                  <a:srgbClr val="D6D3F0"/>
+                  <a:srgbClr val="C9C1B1"/>
                 </a:solidFill>
                 <a:latin typeface="Noto Sans TC"/>
                 <a:ea typeface="Noto Sans TC"/>
@@ -13990,13 +13990,13 @@
             </a:avLst>
           </a:prstGeom>
           <a:solidFill>
-            <a:srgbClr val="FFFFFF">
+            <a:srgbClr val="EEE9DF">
               <a:alpha val="12000"/>
             </a:srgbClr>
           </a:solidFill>
           <a:ln w="9525">
             <a:solidFill>
-              <a:srgbClr val="FFFFFF">
+              <a:srgbClr val="EEE9DF">
                 <a:alpha val="35000"/>
               </a:srgbClr>
             </a:solidFill>
@@ -14043,7 +14043,7 @@
             <a:r>
               <a:rPr sz="1600" b="1" lang="zh-TW">
                 <a:solidFill>
-                  <a:srgbClr val="00F2FE"/>
+                  <a:srgbClr val="FFB162"/>
                 </a:solidFill>
                 <a:latin typeface="Noto Sans TC"/>
                 <a:ea typeface="Noto Sans TC"/>
@@ -14069,7 +14069,7 @@
             <a:avLst/>
           </a:prstGeom>
           <a:solidFill>
-            <a:srgbClr val="00F2FE"/>
+            <a:srgbClr val="FFB162"/>
           </a:solidFill>
           <a:ln>
             <a:noFill/>
@@ -14109,7 +14109,7 @@
             <a:r>
               <a:rPr sz="1400" b="0" lang="zh-TW">
                 <a:solidFill>
-                  <a:srgbClr val="FFFFFF"/>
+                  <a:srgbClr val="EEE9DF"/>
                 </a:solidFill>
                 <a:latin typeface="Noto Sans TC"/>
                 <a:ea typeface="Noto Sans TC"/>
@@ -14135,7 +14135,7 @@
             <a:avLst/>
           </a:prstGeom>
           <a:solidFill>
-            <a:srgbClr val="00F2FE"/>
+            <a:srgbClr val="FFB162"/>
           </a:solidFill>
           <a:ln>
             <a:noFill/>
@@ -14175,7 +14175,7 @@
             <a:r>
               <a:rPr sz="1400" b="0" lang="zh-TW">
                 <a:solidFill>
-                  <a:srgbClr val="FFFFFF"/>
+                  <a:srgbClr val="EEE9DF"/>
                 </a:solidFill>
                 <a:latin typeface="Noto Sans TC"/>
                 <a:ea typeface="Noto Sans TC"/>
@@ -14201,7 +14201,7 @@
             <a:avLst/>
           </a:prstGeom>
           <a:solidFill>
-            <a:srgbClr val="00F2FE"/>
+            <a:srgbClr val="FFB162"/>
           </a:solidFill>
           <a:ln>
             <a:noFill/>
@@ -14241,7 +14241,7 @@
             <a:r>
               <a:rPr sz="1400" b="0" lang="zh-TW">
                 <a:solidFill>
-                  <a:srgbClr val="FFFFFF"/>
+                  <a:srgbClr val="EEE9DF"/>
                 </a:solidFill>
                 <a:latin typeface="Noto Sans TC"/>
                 <a:ea typeface="Noto Sans TC"/>
@@ -14267,7 +14267,7 @@
             <a:avLst/>
           </a:prstGeom>
           <a:solidFill>
-            <a:srgbClr val="00F2FE"/>
+            <a:srgbClr val="FFB162"/>
           </a:solidFill>
           <a:ln>
             <a:noFill/>
@@ -14307,7 +14307,7 @@
             <a:r>
               <a:rPr sz="1400" b="0" lang="zh-TW">
                 <a:solidFill>
-                  <a:srgbClr val="FFFFFF"/>
+                  <a:srgbClr val="EEE9DF"/>
                 </a:solidFill>
                 <a:latin typeface="Noto Sans TC"/>
                 <a:ea typeface="Noto Sans TC"/>
@@ -14335,13 +14335,13 @@
             </a:avLst>
           </a:prstGeom>
           <a:solidFill>
-            <a:srgbClr val="FFFFFF">
+            <a:srgbClr val="EEE9DF">
               <a:alpha val="12000"/>
             </a:srgbClr>
           </a:solidFill>
           <a:ln w="9525">
             <a:solidFill>
-              <a:srgbClr val="FFFFFF">
+              <a:srgbClr val="EEE9DF">
                 <a:alpha val="35000"/>
               </a:srgbClr>
             </a:solidFill>
@@ -14388,7 +14388,7 @@
             <a:r>
               <a:rPr sz="1600" b="1" lang="zh-TW">
                 <a:solidFill>
-                  <a:srgbClr val="FFFFFF"/>
+                  <a:srgbClr val="EEE9DF"/>
                 </a:solidFill>
                 <a:latin typeface="Noto Sans TC"/>
                 <a:ea typeface="Noto Sans TC"/>
@@ -14414,7 +14414,7 @@
             <a:avLst/>
           </a:prstGeom>
           <a:solidFill>
-            <a:srgbClr val="D6D3F0"/>
+            <a:srgbClr val="C9C1B1"/>
           </a:solidFill>
           <a:ln>
             <a:noFill/>
@@ -14454,7 +14454,7 @@
             <a:r>
               <a:rPr sz="1400" b="0" lang="zh-TW">
                 <a:solidFill>
-                  <a:srgbClr val="FFFFFF"/>
+                  <a:srgbClr val="EEE9DF"/>
                 </a:solidFill>
                 <a:latin typeface="Noto Sans TC"/>
                 <a:ea typeface="Noto Sans TC"/>
@@ -14480,7 +14480,7 @@
             <a:avLst/>
           </a:prstGeom>
           <a:solidFill>
-            <a:srgbClr val="D6D3F0"/>
+            <a:srgbClr val="C9C1B1"/>
           </a:solidFill>
           <a:ln>
             <a:noFill/>
@@ -14520,7 +14520,7 @@
             <a:r>
               <a:rPr sz="1400" b="0" lang="zh-TW">
                 <a:solidFill>
-                  <a:srgbClr val="FFFFFF"/>
+                  <a:srgbClr val="EEE9DF"/>
                 </a:solidFill>
                 <a:latin typeface="Noto Sans TC"/>
                 <a:ea typeface="Noto Sans TC"/>
@@ -14546,7 +14546,7 @@
             <a:avLst/>
           </a:prstGeom>
           <a:solidFill>
-            <a:srgbClr val="D6D3F0"/>
+            <a:srgbClr val="C9C1B1"/>
           </a:solidFill>
           <a:ln>
             <a:noFill/>
@@ -14586,7 +14586,7 @@
             <a:r>
               <a:rPr sz="1400" b="0" lang="zh-TW">
                 <a:solidFill>
-                  <a:srgbClr val="FFFFFF"/>
+                  <a:srgbClr val="EEE9DF"/>
                 </a:solidFill>
                 <a:latin typeface="Noto Sans TC"/>
                 <a:ea typeface="Noto Sans TC"/>
@@ -14612,7 +14612,7 @@
             <a:avLst/>
           </a:prstGeom>
           <a:solidFill>
-            <a:srgbClr val="D6D3F0"/>
+            <a:srgbClr val="C9C1B1"/>
           </a:solidFill>
           <a:ln>
             <a:noFill/>
@@ -14652,7 +14652,7 @@
             <a:r>
               <a:rPr sz="1400" b="0" lang="zh-TW">
                 <a:solidFill>
-                  <a:srgbClr val="FFFFFF"/>
+                  <a:srgbClr val="EEE9DF"/>
                 </a:solidFill>
                 <a:latin typeface="Noto Sans TC"/>
                 <a:ea typeface="Noto Sans TC"/>
@@ -14689,7 +14689,7 @@
             <a:r>
               <a:rPr sz="1400" b="1" lang="zh-TW">
                 <a:solidFill>
-                  <a:srgbClr val="00F2FE"/>
+                  <a:srgbClr val="FFB162"/>
                 </a:solidFill>
                 <a:latin typeface="Noto Sans TC"/>
                 <a:ea typeface="Noto Sans TC"/>
@@ -14761,7 +14761,7 @@
                                         <p:strVal val="visible"/>
                                       </p:to>
                                     </p:set>
-                                    <p:animEffect transition="in" filter="wipe(right)">
+                                    <p:animEffect transition="in" filter="wipe(left)">
                                       <p:cBhvr>
                                         <p:cTn id="7" dur="400"/>
                                         <p:tgtEl>
@@ -14796,7 +14796,7 @@
                                         <p:strVal val="visible"/>
                                       </p:to>
                                     </p:set>
-                                    <p:animEffect transition="in" filter="wipe(right)">
+                                    <p:animEffect transition="in" filter="wipe(left)">
                                       <p:cBhvr>
                                         <p:cTn id="10" dur="400"/>
                                         <p:tgtEl>
@@ -14831,7 +14831,7 @@
                                         <p:strVal val="visible"/>
                                       </p:to>
                                     </p:set>
-                                    <p:animEffect transition="in" filter="wipe(right)">
+                                    <p:animEffect transition="in" filter="wipe(left)">
                                       <p:cBhvr>
                                         <p:cTn id="13" dur="400"/>
                                         <p:tgtEl>
@@ -14866,7 +14866,7 @@
                                         <p:strVal val="visible"/>
                                       </p:to>
                                     </p:set>
-                                    <p:animEffect transition="in" filter="wipe(right)">
+                                    <p:animEffect transition="in" filter="wipe(left)">
                                       <p:cBhvr>
                                         <p:cTn id="16" dur="400"/>
                                         <p:tgtEl>
@@ -14901,7 +14901,7 @@
                                         <p:strVal val="visible"/>
                                       </p:to>
                                     </p:set>
-                                    <p:animEffect transition="in" filter="wipe(right)">
+                                    <p:animEffect transition="in" filter="wipe(left)">
                                       <p:cBhvr>
                                         <p:cTn id="19" dur="400"/>
                                         <p:tgtEl>
@@ -14936,7 +14936,7 @@
                                         <p:strVal val="visible"/>
                                       </p:to>
                                     </p:set>
-                                    <p:animEffect transition="in" filter="wipe(right)">
+                                    <p:animEffect transition="in" filter="wipe(left)">
                                       <p:cBhvr>
                                         <p:cTn id="22" dur="400"/>
                                         <p:tgtEl>
@@ -14971,7 +14971,7 @@
                                         <p:strVal val="visible"/>
                                       </p:to>
                                     </p:set>
-                                    <p:animEffect transition="in" filter="wipe(right)">
+                                    <p:animEffect transition="in" filter="wipe(left)">
                                       <p:cBhvr>
                                         <p:cTn id="25" dur="400"/>
                                         <p:tgtEl>
@@ -15006,7 +15006,7 @@
                                         <p:strVal val="visible"/>
                                       </p:to>
                                     </p:set>
-                                    <p:animEffect transition="in" filter="wipe(right)">
+                                    <p:animEffect transition="in" filter="wipe(left)">
                                       <p:cBhvr>
                                         <p:cTn id="28" dur="400"/>
                                         <p:tgtEl>
@@ -15041,7 +15041,7 @@
                                         <p:strVal val="visible"/>
                                       </p:to>
                                     </p:set>
-                                    <p:animEffect transition="in" filter="wipe(right)">
+                                    <p:animEffect transition="in" filter="wipe(left)">
                                       <p:cBhvr>
                                         <p:cTn id="31" dur="400"/>
                                         <p:tgtEl>
@@ -15076,7 +15076,7 @@
                                         <p:strVal val="visible"/>
                                       </p:to>
                                     </p:set>
-                                    <p:animEffect transition="in" filter="wipe(right)">
+                                    <p:animEffect transition="in" filter="wipe(left)">
                                       <p:cBhvr>
                                         <p:cTn id="34" dur="400"/>
                                         <p:tgtEl>
@@ -15129,7 +15129,7 @@
                                         <p:strVal val="visible"/>
                                       </p:to>
                                     </p:set>
-                                    <p:animEffect transition="in" filter="wipe(left)">
+                                    <p:animEffect transition="in" filter="wipe(right)">
                                       <p:cBhvr>
                                         <p:cTn id="39" dur="400"/>
                                         <p:tgtEl>
@@ -15164,7 +15164,7 @@
                                         <p:strVal val="visible"/>
                                       </p:to>
                                     </p:set>
-                                    <p:animEffect transition="in" filter="wipe(left)">
+                                    <p:animEffect transition="in" filter="wipe(right)">
                                       <p:cBhvr>
                                         <p:cTn id="42" dur="400"/>
                                         <p:tgtEl>
@@ -15199,7 +15199,7 @@
                                         <p:strVal val="visible"/>
                                       </p:to>
                                     </p:set>
-                                    <p:animEffect transition="in" filter="wipe(left)">
+                                    <p:animEffect transition="in" filter="wipe(right)">
                                       <p:cBhvr>
                                         <p:cTn id="45" dur="400"/>
                                         <p:tgtEl>
@@ -15234,7 +15234,7 @@
                                         <p:strVal val="visible"/>
                                       </p:to>
                                     </p:set>
-                                    <p:animEffect transition="in" filter="wipe(left)">
+                                    <p:animEffect transition="in" filter="wipe(right)">
                                       <p:cBhvr>
                                         <p:cTn id="48" dur="400"/>
                                         <p:tgtEl>
@@ -15269,7 +15269,7 @@
                                         <p:strVal val="visible"/>
                                       </p:to>
                                     </p:set>
-                                    <p:animEffect transition="in" filter="wipe(left)">
+                                    <p:animEffect transition="in" filter="wipe(right)">
                                       <p:cBhvr>
                                         <p:cTn id="51" dur="400"/>
                                         <p:tgtEl>
@@ -15304,7 +15304,7 @@
                                         <p:strVal val="visible"/>
                                       </p:to>
                                     </p:set>
-                                    <p:animEffect transition="in" filter="wipe(left)">
+                                    <p:animEffect transition="in" filter="wipe(right)">
                                       <p:cBhvr>
                                         <p:cTn id="54" dur="400"/>
                                         <p:tgtEl>
@@ -15339,7 +15339,7 @@
                                         <p:strVal val="visible"/>
                                       </p:to>
                                     </p:set>
-                                    <p:animEffect transition="in" filter="wipe(left)">
+                                    <p:animEffect transition="in" filter="wipe(right)">
                                       <p:cBhvr>
                                         <p:cTn id="57" dur="400"/>
                                         <p:tgtEl>
@@ -15374,7 +15374,7 @@
                                         <p:strVal val="visible"/>
                                       </p:to>
                                     </p:set>
-                                    <p:animEffect transition="in" filter="wipe(left)">
+                                    <p:animEffect transition="in" filter="wipe(right)">
                                       <p:cBhvr>
                                         <p:cTn id="60" dur="400"/>
                                         <p:tgtEl>
@@ -15409,7 +15409,7 @@
                                         <p:strVal val="visible"/>
                                       </p:to>
                                     </p:set>
-                                    <p:animEffect transition="in" filter="wipe(left)">
+                                    <p:animEffect transition="in" filter="wipe(right)">
                                       <p:cBhvr>
                                         <p:cTn id="63" dur="400"/>
                                         <p:tgtEl>
@@ -15444,7 +15444,7 @@
                                         <p:strVal val="visible"/>
                                       </p:to>
                                     </p:set>
-                                    <p:animEffect transition="in" filter="wipe(left)">
+                                    <p:animEffect transition="in" filter="wipe(right)">
                                       <p:cBhvr>
                                         <p:cTn id="66" dur="400"/>
                                         <p:tgtEl>
@@ -15652,10 +15652,10 @@
         <a:gradFill rotWithShape="1">
           <a:gsLst>
             <a:gs pos="0">
-              <a:srgbClr val="1F1C5C"/>
+              <a:srgbClr val="1B2632"/>
             </a:gs>
             <a:gs pos="100000">
-              <a:srgbClr val="5B1F6E"/>
+              <a:srgbClr val="2C3B4D"/>
             </a:gs>
           </a:gsLst>
           <a:lin scaled="0" ang="2700000"/>
@@ -15672,7 +15672,7 @@
       <p:grpSpPr/>
       <p:sp>
         <p:nvSpPr>
-          <p:cNvPr id="2" name="!!orb-violet"/>
+          <p:cNvPr id="2" name="!!orb-orange"/>
           <p:cNvSpPr/>
           <p:nvPr/>
         </p:nvSpPr>
@@ -15685,8 +15685,8 @@
             <a:avLst/>
           </a:prstGeom>
           <a:solidFill>
-            <a:srgbClr val="667EEA">
-              <a:alpha val="55000"/>
+            <a:srgbClr val="FFB162">
+              <a:alpha val="35000"/>
             </a:srgbClr>
           </a:solidFill>
           <a:ln>
@@ -15706,7 +15706,7 @@
       </p:sp>
       <p:sp>
         <p:nvSpPr>
-          <p:cNvPr id="3" name="!!orb-pink"/>
+          <p:cNvPr id="3" name="!!orb-rust"/>
           <p:cNvSpPr/>
           <p:nvPr/>
         </p:nvSpPr>
@@ -15719,8 +15719,8 @@
             <a:avLst/>
           </a:prstGeom>
           <a:solidFill>
-            <a:srgbClr val="F093FB">
-              <a:alpha val="45000"/>
+            <a:srgbClr val="A35139">
+              <a:alpha val="55000"/>
             </a:srgbClr>
           </a:solidFill>
           <a:ln>
@@ -15740,7 +15740,7 @@
       </p:sp>
       <p:sp>
         <p:nvSpPr>
-          <p:cNvPr id="4" name="!!orb-cyan"/>
+          <p:cNvPr id="4" name="!!orb-cream"/>
           <p:cNvSpPr/>
           <p:nvPr/>
         </p:nvSpPr>
@@ -15753,8 +15753,8 @@
             <a:avLst/>
           </a:prstGeom>
           <a:solidFill>
-            <a:srgbClr val="00F2FE">
-              <a:alpha val="30000"/>
+            <a:srgbClr val="EEE9DF">
+              <a:alpha val="12000"/>
             </a:srgbClr>
           </a:solidFill>
           <a:ln>
@@ -15798,7 +15798,7 @@
             <a:r>
               <a:rPr sz="2600" b="1" lang="zh-TW">
                 <a:solidFill>
-                  <a:srgbClr val="FFFFFF"/>
+                  <a:srgbClr val="EEE9DF"/>
                 </a:solidFill>
                 <a:effectLst>
                   <a:outerShdw blurRad="50800" dist="19050" dir="5400000" algn="ctr" rotWithShape="0">
@@ -15842,7 +15842,7 @@
             <a:r>
               <a:rPr sz="1050" b="0" lang="zh-TW">
                 <a:solidFill>
-                  <a:srgbClr val="D6D3F0"/>
+                  <a:srgbClr val="C9C1B1"/>
                 </a:solidFill>
                 <a:latin typeface="Noto Sans TC"/>
                 <a:ea typeface="Noto Sans TC"/>
@@ -15879,7 +15879,7 @@
             <a:r>
               <a:rPr sz="1050" b="0" lang="zh-TW">
                 <a:solidFill>
-                  <a:srgbClr val="D6D3F0"/>
+                  <a:srgbClr val="C9C1B1"/>
                 </a:solidFill>
                 <a:latin typeface="Noto Sans TC"/>
                 <a:ea typeface="Noto Sans TC"/>
@@ -15907,13 +15907,13 @@
             </a:avLst>
           </a:prstGeom>
           <a:solidFill>
-            <a:srgbClr val="FFFFFF">
+            <a:srgbClr val="EEE9DF">
               <a:alpha val="12000"/>
             </a:srgbClr>
           </a:solidFill>
           <a:ln w="9525">
             <a:solidFill>
-              <a:srgbClr val="FFFFFF">
+              <a:srgbClr val="EEE9DF">
                 <a:alpha val="35000"/>
               </a:srgbClr>
             </a:solidFill>
@@ -15936,7 +15936,7 @@
             <a:r>
               <a:rPr sz="1050" b="0" lang="zh-TW">
                 <a:solidFill>
-                  <a:srgbClr val="00F2FE"/>
+                  <a:srgbClr val="FFB162"/>
                 </a:solidFill>
                 <a:latin typeface="Noto Sans TC"/>
                 <a:ea typeface="Noto Sans TC"/>
@@ -15950,7 +15950,7 @@
             <a:r>
               <a:rPr sz="1300" b="1" lang="zh-TW">
                 <a:solidFill>
-                  <a:srgbClr val="FFFFFF"/>
+                  <a:srgbClr val="EEE9DF"/>
                 </a:solidFill>
                 <a:latin typeface="Noto Sans TC"/>
                 <a:ea typeface="Noto Sans TC"/>
@@ -15978,13 +15978,13 @@
             </a:avLst>
           </a:prstGeom>
           <a:solidFill>
-            <a:srgbClr val="FFFFFF">
+            <a:srgbClr val="EEE9DF">
               <a:alpha val="12000"/>
             </a:srgbClr>
           </a:solidFill>
           <a:ln w="9525">
             <a:solidFill>
-              <a:srgbClr val="FFFFFF">
+              <a:srgbClr val="EEE9DF">
                 <a:alpha val="35000"/>
               </a:srgbClr>
             </a:solidFill>
@@ -16007,7 +16007,7 @@
             <a:r>
               <a:rPr sz="1050" b="0" lang="zh-TW">
                 <a:solidFill>
-                  <a:srgbClr val="00F2FE"/>
+                  <a:srgbClr val="FFB162"/>
                 </a:solidFill>
                 <a:latin typeface="Noto Sans TC"/>
                 <a:ea typeface="Noto Sans TC"/>
@@ -16021,7 +16021,7 @@
             <a:r>
               <a:rPr sz="1300" b="1" lang="zh-TW">
                 <a:solidFill>
-                  <a:srgbClr val="FFFFFF"/>
+                  <a:srgbClr val="EEE9DF"/>
                 </a:solidFill>
                 <a:latin typeface="Noto Sans TC"/>
                 <a:ea typeface="Noto Sans TC"/>
@@ -16051,18 +16051,18 @@
             </a:avLst>
           </a:prstGeom>
           <a:solidFill>
-            <a:srgbClr val="00F2FE">
-              <a:alpha val="20000"/>
+            <a:srgbClr val="2C3B4D">
+              <a:alpha val="85000"/>
             </a:srgbClr>
           </a:solidFill>
           <a:ln w="15875">
             <a:solidFill>
-              <a:srgbClr val="00F2FE"/>
+              <a:srgbClr val="FFB162"/>
             </a:solidFill>
           </a:ln>
           <a:effectLst>
             <a:glow rad="101600">
-              <a:srgbClr val="00F2FE">
+              <a:srgbClr val="FFB162">
                 <a:alpha val="45000"/>
               </a:srgbClr>
             </a:glow>
@@ -16083,7 +16083,7 @@
             <a:r>
               <a:rPr sz="1050" b="0" lang="zh-TW">
                 <a:solidFill>
-                  <a:srgbClr val="00F2FE"/>
+                  <a:srgbClr val="FFB162"/>
                 </a:solidFill>
                 <a:latin typeface="Noto Sans TC"/>
                 <a:ea typeface="Noto Sans TC"/>
@@ -16097,7 +16097,7 @@
             <a:r>
               <a:rPr sz="1300" b="1" lang="zh-TW">
                 <a:solidFill>
-                  <a:srgbClr val="FFFFFF"/>
+                  <a:srgbClr val="EEE9DF"/>
                 </a:solidFill>
                 <a:latin typeface="Noto Sans TC"/>
                 <a:ea typeface="Noto Sans TC"/>
@@ -16127,13 +16127,13 @@
             </a:avLst>
           </a:prstGeom>
           <a:solidFill>
-            <a:srgbClr val="FFFFFF">
+            <a:srgbClr val="EEE9DF">
               <a:alpha val="12000"/>
             </a:srgbClr>
           </a:solidFill>
           <a:ln w="9525">
             <a:solidFill>
-              <a:srgbClr val="FFFFFF">
+              <a:srgbClr val="EEE9DF">
                 <a:alpha val="35000"/>
               </a:srgbClr>
             </a:solidFill>
@@ -16156,7 +16156,7 @@
             <a:r>
               <a:rPr sz="1050" b="0" lang="zh-TW">
                 <a:solidFill>
-                  <a:srgbClr val="00F2FE"/>
+                  <a:srgbClr val="FFB162"/>
                 </a:solidFill>
                 <a:latin typeface="Noto Sans TC"/>
                 <a:ea typeface="Noto Sans TC"/>
@@ -16170,7 +16170,7 @@
             <a:r>
               <a:rPr sz="1300" b="1" lang="zh-TW">
                 <a:solidFill>
-                  <a:srgbClr val="FFFFFF"/>
+                  <a:srgbClr val="EEE9DF"/>
                 </a:solidFill>
                 <a:latin typeface="Noto Sans TC"/>
                 <a:ea typeface="Noto Sans TC"/>
@@ -16200,18 +16200,18 @@
             </a:avLst>
           </a:prstGeom>
           <a:solidFill>
-            <a:srgbClr val="00F2FE">
-              <a:alpha val="20000"/>
+            <a:srgbClr val="2C3B4D">
+              <a:alpha val="85000"/>
             </a:srgbClr>
           </a:solidFill>
           <a:ln w="15875">
             <a:solidFill>
-              <a:srgbClr val="00F2FE"/>
+              <a:srgbClr val="FFB162"/>
             </a:solidFill>
           </a:ln>
           <a:effectLst>
             <a:glow rad="101600">
-              <a:srgbClr val="00F2FE">
+              <a:srgbClr val="FFB162">
                 <a:alpha val="45000"/>
               </a:srgbClr>
             </a:glow>
@@ -16232,7 +16232,7 @@
             <a:r>
               <a:rPr sz="1050" b="0" lang="zh-TW">
                 <a:solidFill>
-                  <a:srgbClr val="00F2FE"/>
+                  <a:srgbClr val="FFB162"/>
                 </a:solidFill>
                 <a:latin typeface="Noto Sans TC"/>
                 <a:ea typeface="Noto Sans TC"/>
@@ -16246,7 +16246,7 @@
             <a:r>
               <a:rPr sz="1300" b="1" lang="zh-TW">
                 <a:solidFill>
-                  <a:srgbClr val="FFFFFF"/>
+                  <a:srgbClr val="EEE9DF"/>
                 </a:solidFill>
                 <a:latin typeface="Noto Sans TC"/>
                 <a:ea typeface="Noto Sans TC"/>
@@ -16274,13 +16274,13 @@
             </a:avLst>
           </a:prstGeom>
           <a:solidFill>
-            <a:srgbClr val="FFFFFF">
+            <a:srgbClr val="EEE9DF">
               <a:alpha val="12000"/>
             </a:srgbClr>
           </a:solidFill>
           <a:ln w="9525">
             <a:solidFill>
-              <a:srgbClr val="FFFFFF">
+              <a:srgbClr val="EEE9DF">
                 <a:alpha val="35000"/>
               </a:srgbClr>
             </a:solidFill>
@@ -16303,7 +16303,7 @@
             <a:r>
               <a:rPr sz="1050" b="0" lang="zh-TW">
                 <a:solidFill>
-                  <a:srgbClr val="00F2FE"/>
+                  <a:srgbClr val="FFB162"/>
                 </a:solidFill>
                 <a:latin typeface="Noto Sans TC"/>
                 <a:ea typeface="Noto Sans TC"/>
@@ -16317,7 +16317,7 @@
             <a:r>
               <a:rPr sz="1300" b="1" lang="zh-TW">
                 <a:solidFill>
-                  <a:srgbClr val="FFFFFF"/>
+                  <a:srgbClr val="EEE9DF"/>
                 </a:solidFill>
                 <a:latin typeface="Noto Sans TC"/>
                 <a:ea typeface="Noto Sans TC"/>
@@ -16329,7 +16329,7 @@
             <a:r>
               <a:rPr sz="1300" b="1" lang="zh-TW">
                 <a:solidFill>
-                  <a:srgbClr val="FFFFFF"/>
+                  <a:srgbClr val="EEE9DF"/>
                 </a:solidFill>
                 <a:latin typeface="Noto Sans TC"/>
                 <a:ea typeface="Noto Sans TC"/>
@@ -16357,13 +16357,13 @@
             </a:avLst>
           </a:prstGeom>
           <a:solidFill>
-            <a:srgbClr val="FFFFFF">
+            <a:srgbClr val="EEE9DF">
               <a:alpha val="12000"/>
             </a:srgbClr>
           </a:solidFill>
           <a:ln w="9525">
             <a:solidFill>
-              <a:srgbClr val="FFFFFF">
+              <a:srgbClr val="EEE9DF">
                 <a:alpha val="35000"/>
               </a:srgbClr>
             </a:solidFill>
@@ -16386,7 +16386,7 @@
             <a:r>
               <a:rPr sz="1050" b="0" lang="zh-TW">
                 <a:solidFill>
-                  <a:srgbClr val="00F2FE"/>
+                  <a:srgbClr val="FFB162"/>
                 </a:solidFill>
                 <a:latin typeface="Noto Sans TC"/>
                 <a:ea typeface="Noto Sans TC"/>
@@ -16400,7 +16400,7 @@
             <a:r>
               <a:rPr sz="1300" b="1" lang="zh-TW">
                 <a:solidFill>
-                  <a:srgbClr val="FFFFFF"/>
+                  <a:srgbClr val="EEE9DF"/>
                 </a:solidFill>
                 <a:latin typeface="Noto Sans TC"/>
                 <a:ea typeface="Noto Sans TC"/>
@@ -16430,18 +16430,18 @@
             </a:avLst>
           </a:prstGeom>
           <a:solidFill>
-            <a:srgbClr val="00F2FE">
-              <a:alpha val="20000"/>
+            <a:srgbClr val="2C3B4D">
+              <a:alpha val="85000"/>
             </a:srgbClr>
           </a:solidFill>
           <a:ln w="15875">
             <a:solidFill>
-              <a:srgbClr val="00F2FE"/>
+              <a:srgbClr val="FFB162"/>
             </a:solidFill>
           </a:ln>
           <a:effectLst>
             <a:glow rad="101600">
-              <a:srgbClr val="00F2FE">
+              <a:srgbClr val="FFB162">
                 <a:alpha val="45000"/>
               </a:srgbClr>
             </a:glow>
@@ -16462,7 +16462,7 @@
             <a:r>
               <a:rPr sz="1050" b="0" lang="zh-TW">
                 <a:solidFill>
-                  <a:srgbClr val="00F2FE"/>
+                  <a:srgbClr val="FFB162"/>
                 </a:solidFill>
                 <a:latin typeface="Noto Sans TC"/>
                 <a:ea typeface="Noto Sans TC"/>
@@ -16476,7 +16476,7 @@
             <a:r>
               <a:rPr sz="1300" b="1" lang="zh-TW">
                 <a:solidFill>
-                  <a:srgbClr val="FFFFFF"/>
+                  <a:srgbClr val="EEE9DF"/>
                 </a:solidFill>
                 <a:latin typeface="Noto Sans TC"/>
                 <a:ea typeface="Noto Sans TC"/>
@@ -16506,7 +16506,7 @@
           </a:prstGeom>
           <a:ln w="15875">
             <a:solidFill>
-              <a:srgbClr val="B8B4E0"/>
+              <a:srgbClr val="C9C1B1"/>
             </a:solidFill>
             <a:tailEnd type="triangle"/>
           </a:ln>
@@ -16545,7 +16545,7 @@
           </a:prstGeom>
           <a:ln w="15875">
             <a:solidFill>
-              <a:srgbClr val="B8B4E0"/>
+              <a:srgbClr val="C9C1B1"/>
             </a:solidFill>
             <a:tailEnd type="triangle"/>
           </a:ln>
@@ -16584,7 +16584,7 @@
           </a:prstGeom>
           <a:ln w="15875">
             <a:solidFill>
-              <a:srgbClr val="B8B4E0"/>
+              <a:srgbClr val="C9C1B1"/>
             </a:solidFill>
             <a:tailEnd type="triangle"/>
           </a:ln>
@@ -16623,7 +16623,7 @@
           </a:prstGeom>
           <a:ln w="15875">
             <a:solidFill>
-              <a:srgbClr val="B8B4E0"/>
+              <a:srgbClr val="C9C1B1"/>
             </a:solidFill>
             <a:tailEnd type="triangle"/>
           </a:ln>
@@ -16662,7 +16662,7 @@
           </a:prstGeom>
           <a:ln w="15875">
             <a:solidFill>
-              <a:srgbClr val="B8B4E0"/>
+              <a:srgbClr val="C9C1B1"/>
             </a:solidFill>
             <a:tailEnd type="triangle"/>
           </a:ln>
@@ -16701,7 +16701,7 @@
           </a:prstGeom>
           <a:ln w="15875">
             <a:solidFill>
-              <a:srgbClr val="B8B4E0"/>
+              <a:srgbClr val="C9C1B1"/>
             </a:solidFill>
             <a:tailEnd type="triangle"/>
           </a:ln>
@@ -16740,7 +16740,7 @@
           </a:prstGeom>
           <a:ln w="15875">
             <a:solidFill>
-              <a:srgbClr val="B8B4E0"/>
+              <a:srgbClr val="C9C1B1"/>
             </a:solidFill>
             <a:tailEnd type="triangle"/>
           </a:ln>
@@ -16786,7 +16786,7 @@
             <a:r>
               <a:rPr sz="1400" b="0" lang="zh-TW">
                 <a:solidFill>
-                  <a:srgbClr val="D6D3F0"/>
+                  <a:srgbClr val="C9C1B1"/>
                 </a:solidFill>
                 <a:latin typeface="Noto Sans TC"/>
                 <a:ea typeface="Noto Sans TC"/>
@@ -17564,10 +17564,10 @@
         <a:gradFill rotWithShape="1">
           <a:gsLst>
             <a:gs pos="0">
-              <a:srgbClr val="1F1C5C"/>
+              <a:srgbClr val="1B2632"/>
             </a:gs>
             <a:gs pos="100000">
-              <a:srgbClr val="5B1F6E"/>
+              <a:srgbClr val="2C3B4D"/>
             </a:gs>
           </a:gsLst>
           <a:lin scaled="0" ang="2700000"/>
@@ -17584,7 +17584,7 @@
       <p:grpSpPr/>
       <p:sp>
         <p:nvSpPr>
-          <p:cNvPr id="2" name="!!orb-violet"/>
+          <p:cNvPr id="2" name="!!orb-orange"/>
           <p:cNvSpPr/>
           <p:nvPr/>
         </p:nvSpPr>
@@ -17597,8 +17597,8 @@
             <a:avLst/>
           </a:prstGeom>
           <a:solidFill>
-            <a:srgbClr val="667EEA">
-              <a:alpha val="55000"/>
+            <a:srgbClr val="FFB162">
+              <a:alpha val="35000"/>
             </a:srgbClr>
           </a:solidFill>
           <a:ln>
@@ -17618,7 +17618,7 @@
       </p:sp>
       <p:sp>
         <p:nvSpPr>
-          <p:cNvPr id="3" name="!!orb-pink"/>
+          <p:cNvPr id="3" name="!!orb-rust"/>
           <p:cNvSpPr/>
           <p:nvPr/>
         </p:nvSpPr>
@@ -17631,8 +17631,8 @@
             <a:avLst/>
           </a:prstGeom>
           <a:solidFill>
-            <a:srgbClr val="F093FB">
-              <a:alpha val="45000"/>
+            <a:srgbClr val="A35139">
+              <a:alpha val="55000"/>
             </a:srgbClr>
           </a:solidFill>
           <a:ln>
@@ -17652,7 +17652,7 @@
       </p:sp>
       <p:sp>
         <p:nvSpPr>
-          <p:cNvPr id="4" name="!!orb-cyan"/>
+          <p:cNvPr id="4" name="!!orb-cream"/>
           <p:cNvSpPr/>
           <p:nvPr/>
         </p:nvSpPr>
@@ -17665,8 +17665,8 @@
             <a:avLst/>
           </a:prstGeom>
           <a:solidFill>
-            <a:srgbClr val="00F2FE">
-              <a:alpha val="30000"/>
+            <a:srgbClr val="EEE9DF">
+              <a:alpha val="12000"/>
             </a:srgbClr>
           </a:solidFill>
           <a:ln>
@@ -17710,7 +17710,7 @@
             <a:r>
               <a:rPr sz="2600" b="1" lang="zh-TW">
                 <a:solidFill>
-                  <a:srgbClr val="FFFFFF"/>
+                  <a:srgbClr val="EEE9DF"/>
                 </a:solidFill>
                 <a:effectLst>
                   <a:outerShdw blurRad="50800" dist="19050" dir="5400000" algn="ctr" rotWithShape="0">
@@ -17754,7 +17754,7 @@
             <a:r>
               <a:rPr sz="1050" b="0" lang="zh-TW">
                 <a:solidFill>
-                  <a:srgbClr val="D6D3F0"/>
+                  <a:srgbClr val="C9C1B1"/>
                 </a:solidFill>
                 <a:latin typeface="Noto Sans TC"/>
                 <a:ea typeface="Noto Sans TC"/>
@@ -17791,7 +17791,7 @@
             <a:r>
               <a:rPr sz="1050" b="0" lang="zh-TW">
                 <a:solidFill>
-                  <a:srgbClr val="D6D3F0"/>
+                  <a:srgbClr val="C9C1B1"/>
                 </a:solidFill>
                 <a:latin typeface="Noto Sans TC"/>
                 <a:ea typeface="Noto Sans TC"/>
@@ -17819,13 +17819,13 @@
             </a:avLst>
           </a:prstGeom>
           <a:solidFill>
-            <a:srgbClr val="0F0D2E">
+            <a:srgbClr val="111921">
               <a:alpha val="55000"/>
             </a:srgbClr>
           </a:solidFill>
           <a:ln w="9525">
             <a:solidFill>
-              <a:srgbClr val="FFFFFF">
+              <a:srgbClr val="EEE9DF">
                 <a:alpha val="25000"/>
               </a:srgbClr>
             </a:solidFill>
@@ -17865,7 +17865,7 @@
             <a:r>
               <a:rPr sz="1050" b="0" lang="zh-TW">
                 <a:solidFill>
-                  <a:srgbClr val="00F2FE"/>
+                  <a:srgbClr val="FFB162"/>
                 </a:solidFill>
                 <a:latin typeface="Noto Sans TC"/>
                 <a:ea typeface="Noto Sans TC"/>
@@ -17902,7 +17902,7 @@
             <a:r>
               <a:rPr sz="1100" b="0" lang="zh-TW">
                 <a:solidFill>
-                  <a:srgbClr val="FFFFFF"/>
+                  <a:srgbClr val="EEE9DF"/>
                 </a:solidFill>
                 <a:latin typeface="Consolas"/>
                 <a:ea typeface="Noto Sans TC"/>
@@ -17916,7 +17916,7 @@
             <a:r>
               <a:rPr sz="1100" b="0" lang="zh-TW">
                 <a:solidFill>
-                  <a:srgbClr val="FFFFFF"/>
+                  <a:srgbClr val="EEE9DF"/>
                 </a:solidFill>
                 <a:latin typeface="Consolas"/>
                 <a:ea typeface="Noto Sans TC"/>
@@ -17930,7 +17930,7 @@
             <a:r>
               <a:rPr sz="1100" b="0" lang="zh-TW">
                 <a:solidFill>
-                  <a:srgbClr val="FFFFFF"/>
+                  <a:srgbClr val="EEE9DF"/>
                 </a:solidFill>
                 <a:latin typeface="Consolas"/>
                 <a:ea typeface="Noto Sans TC"/>
@@ -17944,7 +17944,7 @@
             <a:r>
               <a:rPr sz="1100" b="0" lang="zh-TW">
                 <a:solidFill>
-                  <a:srgbClr val="FFFFFF"/>
+                  <a:srgbClr val="EEE9DF"/>
                 </a:solidFill>
                 <a:latin typeface="Consolas"/>
                 <a:ea typeface="Noto Sans TC"/>
@@ -17958,7 +17958,7 @@
             <a:r>
               <a:rPr sz="1100" b="0" lang="zh-TW">
                 <a:solidFill>
-                  <a:srgbClr val="FFFFFF"/>
+                  <a:srgbClr val="EEE9DF"/>
                 </a:solidFill>
                 <a:latin typeface="Consolas"/>
                 <a:ea typeface="Noto Sans TC"/>
@@ -17972,7 +17972,7 @@
             <a:r>
               <a:rPr sz="1100" b="0" lang="zh-TW">
                 <a:solidFill>
-                  <a:srgbClr val="FFFFFF"/>
+                  <a:srgbClr val="EEE9DF"/>
                 </a:solidFill>
                 <a:latin typeface="Consolas"/>
                 <a:ea typeface="Noto Sans TC"/>
@@ -17986,7 +17986,7 @@
             <a:r>
               <a:rPr sz="1100" b="0" lang="zh-TW">
                 <a:solidFill>
-                  <a:srgbClr val="FFFFFF"/>
+                  <a:srgbClr val="EEE9DF"/>
                 </a:solidFill>
                 <a:latin typeface="Consolas"/>
                 <a:ea typeface="Noto Sans TC"/>
@@ -18014,13 +18014,13 @@
             </a:avLst>
           </a:prstGeom>
           <a:solidFill>
-            <a:srgbClr val="0F0D2E">
+            <a:srgbClr val="111921">
               <a:alpha val="55000"/>
             </a:srgbClr>
           </a:solidFill>
           <a:ln w="9525">
             <a:solidFill>
-              <a:srgbClr val="FFFFFF">
+              <a:srgbClr val="EEE9DF">
                 <a:alpha val="25000"/>
               </a:srgbClr>
             </a:solidFill>
@@ -18060,7 +18060,7 @@
             <a:r>
               <a:rPr sz="1050" b="0" lang="zh-TW">
                 <a:solidFill>
-                  <a:srgbClr val="00F2FE"/>
+                  <a:srgbClr val="FFB162"/>
                 </a:solidFill>
                 <a:latin typeface="Noto Sans TC"/>
                 <a:ea typeface="Noto Sans TC"/>
@@ -18097,7 +18097,7 @@
             <a:r>
               <a:rPr sz="1100" b="0" lang="zh-TW">
                 <a:solidFill>
-                  <a:srgbClr val="FFFFFF"/>
+                  <a:srgbClr val="EEE9DF"/>
                 </a:solidFill>
                 <a:latin typeface="Consolas"/>
                 <a:ea typeface="Noto Sans TC"/>
@@ -18111,7 +18111,7 @@
             <a:r>
               <a:rPr sz="1100" b="0" lang="zh-TW">
                 <a:solidFill>
-                  <a:srgbClr val="FFFFFF"/>
+                  <a:srgbClr val="EEE9DF"/>
                 </a:solidFill>
                 <a:latin typeface="Consolas"/>
                 <a:ea typeface="Noto Sans TC"/>
@@ -18125,7 +18125,7 @@
             <a:r>
               <a:rPr sz="1100" b="0" lang="zh-TW">
                 <a:solidFill>
-                  <a:srgbClr val="FFFFFF"/>
+                  <a:srgbClr val="EEE9DF"/>
                 </a:solidFill>
                 <a:latin typeface="Consolas"/>
                 <a:ea typeface="Noto Sans TC"/>
@@ -18151,14 +18151,14 @@
             <a:avLst/>
           </a:prstGeom>
           <a:solidFill>
-            <a:srgbClr val="00F2FE"/>
+            <a:srgbClr val="FFB162"/>
           </a:solidFill>
           <a:ln>
             <a:noFill/>
           </a:ln>
           <a:effectLst>
             <a:glow rad="76200">
-              <a:srgbClr val="00F2FE">
+              <a:srgbClr val="FFB162">
                 <a:alpha val="60000"/>
               </a:srgbClr>
             </a:glow>
@@ -18189,7 +18189,7 @@
           <a:noFill/>
           <a:ln w="15875">
             <a:solidFill>
-              <a:srgbClr val="00F2FE"/>
+              <a:srgbClr val="FFB162"/>
             </a:solidFill>
           </a:ln>
         </p:spPr>
@@ -18203,7 +18203,7 @@
             <a:r>
               <a:rPr sz="1050" b="1" lang="zh-TW">
                 <a:solidFill>
-                  <a:srgbClr val="00F2FE"/>
+                  <a:srgbClr val="FFB162"/>
                 </a:solidFill>
                 <a:latin typeface="Noto Sans TC"/>
                 <a:ea typeface="Noto Sans TC"/>
@@ -18240,7 +18240,7 @@
             <a:r>
               <a:rPr sz="1400" b="0" lang="zh-TW">
                 <a:solidFill>
-                  <a:srgbClr val="FFFFFF"/>
+                  <a:srgbClr val="EEE9DF"/>
                 </a:solidFill>
                 <a:latin typeface="Noto Sans TC"/>
                 <a:ea typeface="Noto Sans TC"/>
@@ -18268,7 +18268,7 @@
           <a:noFill/>
           <a:ln w="15875">
             <a:solidFill>
-              <a:srgbClr val="00F2FE"/>
+              <a:srgbClr val="FFB162"/>
             </a:solidFill>
           </a:ln>
         </p:spPr>
@@ -18282,7 +18282,7 @@
             <a:r>
               <a:rPr sz="1050" b="1" lang="zh-TW">
                 <a:solidFill>
-                  <a:srgbClr val="00F2FE"/>
+                  <a:srgbClr val="FFB162"/>
                 </a:solidFill>
                 <a:latin typeface="Noto Sans TC"/>
                 <a:ea typeface="Noto Sans TC"/>
@@ -18319,7 +18319,7 @@
             <a:r>
               <a:rPr sz="1400" b="0" lang="zh-TW">
                 <a:solidFill>
-                  <a:srgbClr val="FFFFFF"/>
+                  <a:srgbClr val="EEE9DF"/>
                 </a:solidFill>
                 <a:latin typeface="Noto Sans TC"/>
                 <a:ea typeface="Noto Sans TC"/>
@@ -18347,7 +18347,7 @@
           <a:noFill/>
           <a:ln w="15875">
             <a:solidFill>
-              <a:srgbClr val="00F2FE"/>
+              <a:srgbClr val="FFB162"/>
             </a:solidFill>
           </a:ln>
         </p:spPr>
@@ -18361,7 +18361,7 @@
             <a:r>
               <a:rPr sz="1050" b="1" lang="zh-TW">
                 <a:solidFill>
-                  <a:srgbClr val="00F2FE"/>
+                  <a:srgbClr val="FFB162"/>
                 </a:solidFill>
                 <a:latin typeface="Noto Sans TC"/>
                 <a:ea typeface="Noto Sans TC"/>
@@ -18398,7 +18398,7 @@
             <a:r>
               <a:rPr sz="1400" b="0" lang="zh-TW">
                 <a:solidFill>
-                  <a:srgbClr val="FFFFFF"/>
+                  <a:srgbClr val="EEE9DF"/>
                 </a:solidFill>
                 <a:latin typeface="Noto Sans TC"/>
                 <a:ea typeface="Noto Sans TC"/>
@@ -19375,10 +19375,10 @@
         <a:gradFill rotWithShape="1">
           <a:gsLst>
             <a:gs pos="0">
-              <a:srgbClr val="1F1C5C"/>
+              <a:srgbClr val="1B2632"/>
             </a:gs>
             <a:gs pos="100000">
-              <a:srgbClr val="5B1F6E"/>
+              <a:srgbClr val="2C3B4D"/>
             </a:gs>
           </a:gsLst>
           <a:lin scaled="0" ang="2700000"/>
@@ -19395,7 +19395,7 @@
       <p:grpSpPr/>
       <p:sp>
         <p:nvSpPr>
-          <p:cNvPr id="2" name="!!orb-violet"/>
+          <p:cNvPr id="2" name="!!orb-orange"/>
           <p:cNvSpPr/>
           <p:nvPr/>
         </p:nvSpPr>
@@ -19408,8 +19408,8 @@
             <a:avLst/>
           </a:prstGeom>
           <a:solidFill>
-            <a:srgbClr val="667EEA">
-              <a:alpha val="55000"/>
+            <a:srgbClr val="FFB162">
+              <a:alpha val="35000"/>
             </a:srgbClr>
           </a:solidFill>
           <a:ln>
@@ -19429,7 +19429,7 @@
       </p:sp>
       <p:sp>
         <p:nvSpPr>
-          <p:cNvPr id="3" name="!!orb-pink"/>
+          <p:cNvPr id="3" name="!!orb-rust"/>
           <p:cNvSpPr/>
           <p:nvPr/>
         </p:nvSpPr>
@@ -19442,8 +19442,8 @@
             <a:avLst/>
           </a:prstGeom>
           <a:solidFill>
-            <a:srgbClr val="F093FB">
-              <a:alpha val="45000"/>
+            <a:srgbClr val="A35139">
+              <a:alpha val="55000"/>
             </a:srgbClr>
           </a:solidFill>
           <a:ln>
@@ -19463,7 +19463,7 @@
       </p:sp>
       <p:sp>
         <p:nvSpPr>
-          <p:cNvPr id="4" name="!!orb-cyan"/>
+          <p:cNvPr id="4" name="!!orb-cream"/>
           <p:cNvSpPr/>
           <p:nvPr/>
         </p:nvSpPr>
@@ -19476,8 +19476,8 @@
             <a:avLst/>
           </a:prstGeom>
           <a:solidFill>
-            <a:srgbClr val="00F2FE">
-              <a:alpha val="30000"/>
+            <a:srgbClr val="EEE9DF">
+              <a:alpha val="12000"/>
             </a:srgbClr>
           </a:solidFill>
           <a:ln>
@@ -19521,7 +19521,7 @@
             <a:r>
               <a:rPr sz="2600" b="1" lang="zh-TW">
                 <a:solidFill>
-                  <a:srgbClr val="FFFFFF"/>
+                  <a:srgbClr val="EEE9DF"/>
                 </a:solidFill>
                 <a:effectLst>
                   <a:outerShdw blurRad="50800" dist="19050" dir="5400000" algn="ctr" rotWithShape="0">
@@ -19565,7 +19565,7 @@
             <a:r>
               <a:rPr sz="1050" b="0" lang="zh-TW">
                 <a:solidFill>
-                  <a:srgbClr val="D6D3F0"/>
+                  <a:srgbClr val="C9C1B1"/>
                 </a:solidFill>
                 <a:latin typeface="Noto Sans TC"/>
                 <a:ea typeface="Noto Sans TC"/>
@@ -19602,7 +19602,7 @@
             <a:r>
               <a:rPr sz="1050" b="0" lang="zh-TW">
                 <a:solidFill>
-                  <a:srgbClr val="D6D3F0"/>
+                  <a:srgbClr val="C9C1B1"/>
                 </a:solidFill>
                 <a:latin typeface="Noto Sans TC"/>
                 <a:ea typeface="Noto Sans TC"/>
@@ -19630,13 +19630,13 @@
             </a:avLst>
           </a:prstGeom>
           <a:solidFill>
-            <a:srgbClr val="FFFFFF">
+            <a:srgbClr val="EEE9DF">
               <a:alpha val="12000"/>
             </a:srgbClr>
           </a:solidFill>
           <a:ln w="9525">
             <a:solidFill>
-              <a:srgbClr val="FFFFFF">
+              <a:srgbClr val="EEE9DF">
                 <a:alpha val="35000"/>
               </a:srgbClr>
             </a:solidFill>
@@ -19659,7 +19659,7 @@
             <a:r>
               <a:rPr sz="1400" b="0" lang="zh-TW">
                 <a:solidFill>
-                  <a:srgbClr val="FFFFFF"/>
+                  <a:srgbClr val="EEE9DF"/>
                 </a:solidFill>
                 <a:latin typeface="Noto Sans TC"/>
                 <a:ea typeface="Noto Sans TC"/>
@@ -19685,13 +19685,13 @@
             <a:avLst/>
           </a:prstGeom>
           <a:solidFill>
-            <a:srgbClr val="FFFFFF">
+            <a:srgbClr val="EEE9DF">
               <a:alpha val="12000"/>
             </a:srgbClr>
           </a:solidFill>
           <a:ln w="9525">
             <a:solidFill>
-              <a:srgbClr val="FFFFFF">
+              <a:srgbClr val="EEE9DF">
                 <a:alpha val="35000"/>
               </a:srgbClr>
             </a:solidFill>
@@ -19714,7 +19714,7 @@
             <a:r>
               <a:rPr sz="1300" b="0" lang="zh-TW">
                 <a:solidFill>
-                  <a:srgbClr val="FFFFFF"/>
+                  <a:srgbClr val="EEE9DF"/>
                 </a:solidFill>
                 <a:latin typeface="Noto Sans TC"/>
                 <a:ea typeface="Noto Sans TC"/>
@@ -19740,13 +19740,13 @@
             <a:avLst/>
           </a:prstGeom>
           <a:solidFill>
-            <a:srgbClr val="FFFFFF">
+            <a:srgbClr val="EEE9DF">
               <a:alpha val="12000"/>
             </a:srgbClr>
           </a:solidFill>
           <a:ln w="9525">
             <a:solidFill>
-              <a:srgbClr val="FFFFFF">
+              <a:srgbClr val="EEE9DF">
                 <a:alpha val="35000"/>
               </a:srgbClr>
             </a:solidFill>
@@ -19769,7 +19769,7 @@
             <a:r>
               <a:rPr sz="1300" b="0" lang="zh-TW">
                 <a:solidFill>
-                  <a:srgbClr val="FFFFFF"/>
+                  <a:srgbClr val="EEE9DF"/>
                 </a:solidFill>
                 <a:latin typeface="Noto Sans TC"/>
                 <a:ea typeface="Noto Sans TC"/>
@@ -19797,13 +19797,13 @@
             </a:avLst>
           </a:prstGeom>
           <a:solidFill>
-            <a:srgbClr val="FFFFFF">
+            <a:srgbClr val="EEE9DF">
               <a:alpha val="12000"/>
             </a:srgbClr>
           </a:solidFill>
           <a:ln w="9525">
             <a:solidFill>
-              <a:srgbClr val="FFFFFF">
+              <a:srgbClr val="EEE9DF">
                 <a:alpha val="35000"/>
               </a:srgbClr>
             </a:solidFill>
@@ -19826,7 +19826,7 @@
             <a:r>
               <a:rPr sz="1400" b="0" lang="zh-TW">
                 <a:solidFill>
-                  <a:srgbClr val="FFFFFF"/>
+                  <a:srgbClr val="EEE9DF"/>
                 </a:solidFill>
                 <a:latin typeface="Noto Sans TC"/>
                 <a:ea typeface="Noto Sans TC"/>
@@ -19854,18 +19854,18 @@
             </a:avLst>
           </a:prstGeom>
           <a:solidFill>
-            <a:srgbClr val="00F2FE">
-              <a:alpha val="20000"/>
+            <a:srgbClr val="2C3B4D">
+              <a:alpha val="85000"/>
             </a:srgbClr>
           </a:solidFill>
           <a:ln w="15875">
             <a:solidFill>
-              <a:srgbClr val="00F2FE"/>
+              <a:srgbClr val="FFB162"/>
             </a:solidFill>
           </a:ln>
           <a:effectLst>
             <a:glow rad="101600">
-              <a:srgbClr val="00F2FE">
+              <a:srgbClr val="FFB162">
                 <a:alpha val="45000"/>
               </a:srgbClr>
             </a:glow>
@@ -19886,7 +19886,7 @@
             <a:r>
               <a:rPr sz="1600" b="1" lang="zh-TW">
                 <a:solidFill>
-                  <a:srgbClr val="FFFFFF"/>
+                  <a:srgbClr val="EEE9DF"/>
                 </a:solidFill>
                 <a:latin typeface="Noto Sans TC"/>
                 <a:ea typeface="Noto Sans TC"/>
@@ -19916,7 +19916,7 @@
           </a:prstGeom>
           <a:ln w="15875">
             <a:solidFill>
-              <a:srgbClr val="B8B4E0"/>
+              <a:srgbClr val="C9C1B1"/>
             </a:solidFill>
             <a:tailEnd type="triangle"/>
           </a:ln>
@@ -19955,7 +19955,7 @@
           </a:prstGeom>
           <a:ln w="15875">
             <a:solidFill>
-              <a:srgbClr val="B8B4E0"/>
+              <a:srgbClr val="C9C1B1"/>
             </a:solidFill>
             <a:tailEnd type="triangle"/>
           </a:ln>
@@ -19994,7 +19994,7 @@
           </a:prstGeom>
           <a:ln w="15875">
             <a:solidFill>
-              <a:srgbClr val="B8B4E0"/>
+              <a:srgbClr val="C9C1B1"/>
             </a:solidFill>
             <a:tailEnd type="triangle"/>
           </a:ln>
@@ -20030,7 +20030,7 @@
           </a:prstGeom>
           <a:ln w="15875">
             <a:solidFill>
-              <a:srgbClr val="B8B4E0"/>
+              <a:srgbClr val="C9C1B1"/>
             </a:solidFill>
             <a:tailEnd type="triangle"/>
           </a:ln>
@@ -20066,7 +20066,7 @@
           </a:prstGeom>
           <a:ln w="15875">
             <a:solidFill>
-              <a:srgbClr val="B8B4E0"/>
+              <a:srgbClr val="C9C1B1"/>
             </a:solidFill>
             <a:tailEnd type="triangle"/>
           </a:ln>
@@ -20112,7 +20112,7 @@
             <a:r>
               <a:rPr sz="1050" b="0" lang="zh-TW">
                 <a:solidFill>
-                  <a:srgbClr val="D6D3F0"/>
+                  <a:srgbClr val="C9C1B1"/>
                 </a:solidFill>
                 <a:latin typeface="Noto Sans TC"/>
                 <a:ea typeface="Noto Sans TC"/>
@@ -20149,7 +20149,7 @@
             <a:r>
               <a:rPr sz="1050" b="0" lang="zh-TW">
                 <a:solidFill>
-                  <a:srgbClr val="D6D3F0"/>
+                  <a:srgbClr val="C9C1B1"/>
                 </a:solidFill>
                 <a:latin typeface="Noto Sans TC"/>
                 <a:ea typeface="Noto Sans TC"/>
@@ -20186,7 +20186,7 @@
             <a:r>
               <a:rPr sz="1050" b="0" lang="zh-TW">
                 <a:solidFill>
-                  <a:srgbClr val="D6D3F0"/>
+                  <a:srgbClr val="C9C1B1"/>
                 </a:solidFill>
                 <a:latin typeface="Noto Sans TC"/>
                 <a:ea typeface="Noto Sans TC"/>
@@ -20223,7 +20223,7 @@
             <a:r>
               <a:rPr sz="1050" b="0" lang="zh-TW">
                 <a:solidFill>
-                  <a:srgbClr val="D6D3F0"/>
+                  <a:srgbClr val="C9C1B1"/>
                 </a:solidFill>
                 <a:latin typeface="Noto Sans TC"/>
                 <a:ea typeface="Noto Sans TC"/>
@@ -20260,7 +20260,7 @@
             <a:r>
               <a:rPr sz="1400" b="1" lang="zh-TW">
                 <a:solidFill>
-                  <a:srgbClr val="00F2FE"/>
+                  <a:srgbClr val="FFB162"/>
                 </a:solidFill>
                 <a:latin typeface="Noto Sans TC"/>
                 <a:ea typeface="Noto Sans TC"/>
@@ -20385,7 +20385,7 @@
                                         <p:strVal val="visible"/>
                                       </p:to>
                                     </p:set>
-                                    <p:animEffect transition="in" filter="wipe(right)">
+                                    <p:animEffect transition="in" filter="wipe(left)">
                                       <p:cBhvr>
                                         <p:cTn id="12" dur="400"/>
                                         <p:tgtEl>
@@ -20473,7 +20473,7 @@
                                         <p:strVal val="visible"/>
                                       </p:to>
                                     </p:set>
-                                    <p:animEffect transition="in" filter="wipe(down)">
+                                    <p:animEffect transition="in" filter="wipe(up)">
                                       <p:cBhvr>
                                         <p:cTn id="20" dur="400"/>
                                         <p:tgtEl>
@@ -20588,7 +20588,7 @@
                                         <p:strVal val="visible"/>
                                       </p:to>
                                     </p:set>
-                                    <p:animEffect transition="in" filter="wipe(right)">
+                                    <p:animEffect transition="in" filter="wipe(left)">
                                       <p:cBhvr>
                                         <p:cTn id="30" dur="400"/>
                                         <p:tgtEl>
@@ -20703,7 +20703,7 @@
                                         <p:strVal val="visible"/>
                                       </p:to>
                                     </p:set>
-                                    <p:animEffect transition="in" filter="wipe(down)">
+                                    <p:animEffect transition="in" filter="wipe(up)">
                                       <p:cBhvr>
                                         <p:cTn id="40" dur="400"/>
                                         <p:tgtEl>
@@ -20783,7 +20783,7 @@
                                         <p:strVal val="visible"/>
                                       </p:to>
                                     </p:set>
-                                    <p:animEffect transition="in" filter="wipe(right)">
+                                    <p:animEffect transition="in" filter="wipe(left)">
                                       <p:cBhvr>
                                         <p:cTn id="47" dur="400"/>
                                         <p:tgtEl>
@@ -20960,10 +20960,10 @@
         <a:gradFill rotWithShape="1">
           <a:gsLst>
             <a:gs pos="0">
-              <a:srgbClr val="1F1C5C"/>
+              <a:srgbClr val="1B2632"/>
             </a:gs>
             <a:gs pos="100000">
-              <a:srgbClr val="5B1F6E"/>
+              <a:srgbClr val="2C3B4D"/>
             </a:gs>
           </a:gsLst>
           <a:lin scaled="0" ang="2700000"/>
@@ -20980,7 +20980,7 @@
       <p:grpSpPr/>
       <p:sp>
         <p:nvSpPr>
-          <p:cNvPr id="2" name="!!orb-violet"/>
+          <p:cNvPr id="2" name="!!orb-orange"/>
           <p:cNvSpPr/>
           <p:nvPr/>
         </p:nvSpPr>
@@ -20993,8 +20993,8 @@
             <a:avLst/>
           </a:prstGeom>
           <a:solidFill>
-            <a:srgbClr val="667EEA">
-              <a:alpha val="55000"/>
+            <a:srgbClr val="FFB162">
+              <a:alpha val="35000"/>
             </a:srgbClr>
           </a:solidFill>
           <a:ln>
@@ -21014,7 +21014,7 @@
       </p:sp>
       <p:sp>
         <p:nvSpPr>
-          <p:cNvPr id="3" name="!!orb-pink"/>
+          <p:cNvPr id="3" name="!!orb-rust"/>
           <p:cNvSpPr/>
           <p:nvPr/>
         </p:nvSpPr>
@@ -21027,8 +21027,8 @@
             <a:avLst/>
           </a:prstGeom>
           <a:solidFill>
-            <a:srgbClr val="F093FB">
-              <a:alpha val="45000"/>
+            <a:srgbClr val="A35139">
+              <a:alpha val="55000"/>
             </a:srgbClr>
           </a:solidFill>
           <a:ln>
@@ -21048,7 +21048,7 @@
       </p:sp>
       <p:sp>
         <p:nvSpPr>
-          <p:cNvPr id="4" name="!!orb-cyan"/>
+          <p:cNvPr id="4" name="!!orb-cream"/>
           <p:cNvSpPr/>
           <p:nvPr/>
         </p:nvSpPr>
@@ -21061,8 +21061,8 @@
             <a:avLst/>
           </a:prstGeom>
           <a:solidFill>
-            <a:srgbClr val="00F2FE">
-              <a:alpha val="30000"/>
+            <a:srgbClr val="EEE9DF">
+              <a:alpha val="12000"/>
             </a:srgbClr>
           </a:solidFill>
           <a:ln>
@@ -21106,7 +21106,7 @@
             <a:r>
               <a:rPr sz="2600" b="1" lang="zh-TW">
                 <a:solidFill>
-                  <a:srgbClr val="FFFFFF"/>
+                  <a:srgbClr val="EEE9DF"/>
                 </a:solidFill>
                 <a:effectLst>
                   <a:outerShdw blurRad="50800" dist="19050" dir="5400000" algn="ctr" rotWithShape="0">
@@ -21150,7 +21150,7 @@
             <a:r>
               <a:rPr sz="1050" b="0" lang="zh-TW">
                 <a:solidFill>
-                  <a:srgbClr val="D6D3F0"/>
+                  <a:srgbClr val="C9C1B1"/>
                 </a:solidFill>
                 <a:latin typeface="Noto Sans TC"/>
                 <a:ea typeface="Noto Sans TC"/>
@@ -21187,7 +21187,7 @@
             <a:r>
               <a:rPr sz="1050" b="0" lang="zh-TW">
                 <a:solidFill>
-                  <a:srgbClr val="D6D3F0"/>
+                  <a:srgbClr val="C9C1B1"/>
                 </a:solidFill>
                 <a:latin typeface="Noto Sans TC"/>
                 <a:ea typeface="Noto Sans TC"/>
@@ -21230,7 +21230,7 @@
                       <a:r>
                         <a:rPr sz="1600" b="1" lang="zh-TW">
                           <a:solidFill>
-                            <a:srgbClr val="1F1C5C"/>
+                            <a:srgbClr val="1B2632"/>
                           </a:solidFill>
                           <a:latin typeface="Noto Sans TC"/>
                           <a:ea typeface="Noto Sans TC"/>
@@ -21249,20 +21249,20 @@
                     </a:lnR>
                     <a:lnT w="9525">
                       <a:solidFill>
-                        <a:srgbClr val="FFFFFF">
+                        <a:srgbClr val="EEE9DF">
                           <a:alpha val="25000"/>
                         </a:srgbClr>
                       </a:solidFill>
                     </a:lnT>
                     <a:lnB w="9525">
                       <a:solidFill>
-                        <a:srgbClr val="FFFFFF">
+                        <a:srgbClr val="EEE9DF">
                           <a:alpha val="25000"/>
                         </a:srgbClr>
                       </a:solidFill>
                     </a:lnB>
                     <a:solidFill>
-                      <a:srgbClr val="00F2FE"/>
+                      <a:srgbClr val="FFB162"/>
                     </a:solidFill>
                   </a:tcPr>
                 </a:tc>
@@ -21275,7 +21275,7 @@
                       <a:r>
                         <a:rPr sz="1600" b="1" lang="zh-TW">
                           <a:solidFill>
-                            <a:srgbClr val="1F1C5C"/>
+                            <a:srgbClr val="1B2632"/>
                           </a:solidFill>
                           <a:latin typeface="Noto Sans TC"/>
                           <a:ea typeface="Noto Sans TC"/>
@@ -21294,20 +21294,20 @@
                     </a:lnR>
                     <a:lnT w="9525">
                       <a:solidFill>
-                        <a:srgbClr val="FFFFFF">
+                        <a:srgbClr val="EEE9DF">
                           <a:alpha val="25000"/>
                         </a:srgbClr>
                       </a:solidFill>
                     </a:lnT>
                     <a:lnB w="9525">
                       <a:solidFill>
-                        <a:srgbClr val="FFFFFF">
+                        <a:srgbClr val="EEE9DF">
                           <a:alpha val="25000"/>
                         </a:srgbClr>
                       </a:solidFill>
                     </a:lnB>
                     <a:solidFill>
-                      <a:srgbClr val="00F2FE"/>
+                      <a:srgbClr val="FFB162"/>
                     </a:solidFill>
                   </a:tcPr>
                 </a:tc>
@@ -21322,7 +21322,7 @@
                       <a:r>
                         <a:rPr sz="1400" b="0" lang="zh-TW">
                           <a:solidFill>
-                            <a:srgbClr val="FFFFFF"/>
+                            <a:srgbClr val="EEE9DF"/>
                           </a:solidFill>
                           <a:latin typeface="Noto Sans TC"/>
                           <a:ea typeface="Noto Sans TC"/>
@@ -21341,20 +21341,20 @@
                     </a:lnR>
                     <a:lnT w="9525">
                       <a:solidFill>
-                        <a:srgbClr val="FFFFFF">
+                        <a:srgbClr val="EEE9DF">
                           <a:alpha val="25000"/>
                         </a:srgbClr>
                       </a:solidFill>
                     </a:lnT>
                     <a:lnB w="9525">
                       <a:solidFill>
-                        <a:srgbClr val="FFFFFF">
+                        <a:srgbClr val="EEE9DF">
                           <a:alpha val="25000"/>
                         </a:srgbClr>
                       </a:solidFill>
                     </a:lnB>
                     <a:solidFill>
-                      <a:srgbClr val="FFFFFF">
+                      <a:srgbClr val="EEE9DF">
                         <a:alpha val="8000"/>
                       </a:srgbClr>
                     </a:solidFill>
@@ -21369,7 +21369,7 @@
                       <a:r>
                         <a:rPr sz="1400" b="0" lang="zh-TW">
                           <a:solidFill>
-                            <a:srgbClr val="FFFFFF"/>
+                            <a:srgbClr val="EEE9DF"/>
                           </a:solidFill>
                           <a:latin typeface="Noto Sans TC"/>
                           <a:ea typeface="Noto Sans TC"/>
@@ -21388,20 +21388,20 @@
                     </a:lnR>
                     <a:lnT w="9525">
                       <a:solidFill>
-                        <a:srgbClr val="FFFFFF">
+                        <a:srgbClr val="EEE9DF">
                           <a:alpha val="25000"/>
                         </a:srgbClr>
                       </a:solidFill>
                     </a:lnT>
                     <a:lnB w="9525">
                       <a:solidFill>
-                        <a:srgbClr val="FFFFFF">
+                        <a:srgbClr val="EEE9DF">
                           <a:alpha val="25000"/>
                         </a:srgbClr>
                       </a:solidFill>
                     </a:lnB>
                     <a:solidFill>
-                      <a:srgbClr val="FFFFFF">
+                      <a:srgbClr val="EEE9DF">
                         <a:alpha val="8000"/>
                       </a:srgbClr>
                     </a:solidFill>
@@ -21418,7 +21418,7 @@
                       <a:r>
                         <a:rPr sz="1400" b="0" lang="zh-TW">
                           <a:solidFill>
-                            <a:srgbClr val="FFFFFF"/>
+                            <a:srgbClr val="EEE9DF"/>
                           </a:solidFill>
                           <a:latin typeface="Noto Sans TC"/>
                           <a:ea typeface="Noto Sans TC"/>
@@ -21437,20 +21437,20 @@
                     </a:lnR>
                     <a:lnT w="9525">
                       <a:solidFill>
-                        <a:srgbClr val="FFFFFF">
+                        <a:srgbClr val="EEE9DF">
                           <a:alpha val="25000"/>
                         </a:srgbClr>
                       </a:solidFill>
                     </a:lnT>
                     <a:lnB w="9525">
                       <a:solidFill>
-                        <a:srgbClr val="FFFFFF">
+                        <a:srgbClr val="EEE9DF">
                           <a:alpha val="25000"/>
                         </a:srgbClr>
                       </a:solidFill>
                     </a:lnB>
                     <a:solidFill>
-                      <a:srgbClr val="FFFFFF">
+                      <a:srgbClr val="EEE9DF">
                         <a:alpha val="14000"/>
                       </a:srgbClr>
                     </a:solidFill>
@@ -21465,7 +21465,7 @@
                       <a:r>
                         <a:rPr sz="1400" b="0" lang="zh-TW">
                           <a:solidFill>
-                            <a:srgbClr val="FFFFFF"/>
+                            <a:srgbClr val="EEE9DF"/>
                           </a:solidFill>
                           <a:latin typeface="Noto Sans TC"/>
                           <a:ea typeface="Noto Sans TC"/>
@@ -21484,20 +21484,20 @@
                     </a:lnR>
                     <a:lnT w="9525">
                       <a:solidFill>
-                        <a:srgbClr val="FFFFFF">
+                        <a:srgbClr val="EEE9DF">
                           <a:alpha val="25000"/>
                         </a:srgbClr>
                       </a:solidFill>
                     </a:lnT>
                     <a:lnB w="9525">
                       <a:solidFill>
-                        <a:srgbClr val="FFFFFF">
+                        <a:srgbClr val="EEE9DF">
                           <a:alpha val="25000"/>
                         </a:srgbClr>
                       </a:solidFill>
                     </a:lnB>
                     <a:solidFill>
-                      <a:srgbClr val="FFFFFF">
+                      <a:srgbClr val="EEE9DF">
                         <a:alpha val="14000"/>
                       </a:srgbClr>
                     </a:solidFill>
@@ -21514,7 +21514,7 @@
                       <a:r>
                         <a:rPr sz="1400" b="0" lang="zh-TW">
                           <a:solidFill>
-                            <a:srgbClr val="FFFFFF"/>
+                            <a:srgbClr val="EEE9DF"/>
                           </a:solidFill>
                           <a:latin typeface="Noto Sans TC"/>
                           <a:ea typeface="Noto Sans TC"/>
@@ -21533,20 +21533,20 @@
                     </a:lnR>
                     <a:lnT w="9525">
                       <a:solidFill>
-                        <a:srgbClr val="FFFFFF">
+                        <a:srgbClr val="EEE9DF">
                           <a:alpha val="25000"/>
                         </a:srgbClr>
                       </a:solidFill>
                     </a:lnT>
                     <a:lnB w="9525">
                       <a:solidFill>
-                        <a:srgbClr val="FFFFFF">
+                        <a:srgbClr val="EEE9DF">
                           <a:alpha val="25000"/>
                         </a:srgbClr>
                       </a:solidFill>
                     </a:lnB>
                     <a:solidFill>
-                      <a:srgbClr val="FFFFFF">
+                      <a:srgbClr val="EEE9DF">
                         <a:alpha val="8000"/>
                       </a:srgbClr>
                     </a:solidFill>
@@ -21561,7 +21561,7 @@
                       <a:r>
                         <a:rPr sz="1400" b="0" lang="zh-TW">
                           <a:solidFill>
-                            <a:srgbClr val="FFFFFF"/>
+                            <a:srgbClr val="EEE9DF"/>
                           </a:solidFill>
                           <a:latin typeface="Noto Sans TC"/>
                           <a:ea typeface="Noto Sans TC"/>
@@ -21580,20 +21580,20 @@
                     </a:lnR>
                     <a:lnT w="9525">
                       <a:solidFill>
-                        <a:srgbClr val="FFFFFF">
+                        <a:srgbClr val="EEE9DF">
                           <a:alpha val="25000"/>
                         </a:srgbClr>
                       </a:solidFill>
                     </a:lnT>
                     <a:lnB w="9525">
                       <a:solidFill>
-                        <a:srgbClr val="FFFFFF">
+                        <a:srgbClr val="EEE9DF">
                           <a:alpha val="25000"/>
                         </a:srgbClr>
                       </a:solidFill>
                     </a:lnB>
                     <a:solidFill>
-                      <a:srgbClr val="FFFFFF">
+                      <a:srgbClr val="EEE9DF">
                         <a:alpha val="8000"/>
                       </a:srgbClr>
                     </a:solidFill>
@@ -21610,7 +21610,7 @@
                       <a:r>
                         <a:rPr sz="1400" b="0" lang="zh-TW">
                           <a:solidFill>
-                            <a:srgbClr val="FFFFFF"/>
+                            <a:srgbClr val="EEE9DF"/>
                           </a:solidFill>
                           <a:latin typeface="Noto Sans TC"/>
                           <a:ea typeface="Noto Sans TC"/>
@@ -21629,20 +21629,20 @@
                     </a:lnR>
                     <a:lnT w="9525">
                       <a:solidFill>
-                        <a:srgbClr val="FFFFFF">
+                        <a:srgbClr val="EEE9DF">
                           <a:alpha val="25000"/>
                         </a:srgbClr>
                       </a:solidFill>
                     </a:lnT>
                     <a:lnB w="9525">
                       <a:solidFill>
-                        <a:srgbClr val="FFFFFF">
+                        <a:srgbClr val="EEE9DF">
                           <a:alpha val="25000"/>
                         </a:srgbClr>
                       </a:solidFill>
                     </a:lnB>
                     <a:solidFill>
-                      <a:srgbClr val="FFFFFF">
+                      <a:srgbClr val="EEE9DF">
                         <a:alpha val="14000"/>
                       </a:srgbClr>
                     </a:solidFill>
@@ -21657,7 +21657,7 @@
                       <a:r>
                         <a:rPr sz="1400" b="0" lang="zh-TW">
                           <a:solidFill>
-                            <a:srgbClr val="FFFFFF"/>
+                            <a:srgbClr val="EEE9DF"/>
                           </a:solidFill>
                           <a:latin typeface="Noto Sans TC"/>
                           <a:ea typeface="Noto Sans TC"/>
@@ -21676,20 +21676,20 @@
                     </a:lnR>
                     <a:lnT w="9525">
                       <a:solidFill>
-                        <a:srgbClr val="FFFFFF">
+                        <a:srgbClr val="EEE9DF">
                           <a:alpha val="25000"/>
                         </a:srgbClr>
                       </a:solidFill>
                     </a:lnT>
                     <a:lnB w="9525">
                       <a:solidFill>
-                        <a:srgbClr val="FFFFFF">
+                        <a:srgbClr val="EEE9DF">
                           <a:alpha val="25000"/>
                         </a:srgbClr>
                       </a:solidFill>
                     </a:lnB>
                     <a:solidFill>
-                      <a:srgbClr val="FFFFFF">
+                      <a:srgbClr val="EEE9DF">
                         <a:alpha val="14000"/>
                       </a:srgbClr>
                     </a:solidFill>
@@ -21706,7 +21706,7 @@
                       <a:r>
                         <a:rPr sz="1400" b="0" lang="zh-TW">
                           <a:solidFill>
-                            <a:srgbClr val="FFFFFF"/>
+                            <a:srgbClr val="EEE9DF"/>
                           </a:solidFill>
                           <a:latin typeface="Noto Sans TC"/>
                           <a:ea typeface="Noto Sans TC"/>
@@ -21725,20 +21725,20 @@
                     </a:lnR>
                     <a:lnT w="9525">
                       <a:solidFill>
-                        <a:srgbClr val="FFFFFF">
+                        <a:srgbClr val="EEE9DF">
                           <a:alpha val="25000"/>
                         </a:srgbClr>
                       </a:solidFill>
                     </a:lnT>
                     <a:lnB w="9525">
                       <a:solidFill>
-                        <a:srgbClr val="FFFFFF">
+                        <a:srgbClr val="EEE9DF">
                           <a:alpha val="25000"/>
                         </a:srgbClr>
                       </a:solidFill>
                     </a:lnB>
                     <a:solidFill>
-                      <a:srgbClr val="FFFFFF">
+                      <a:srgbClr val="EEE9DF">
                         <a:alpha val="8000"/>
                       </a:srgbClr>
                     </a:solidFill>
@@ -21753,7 +21753,7 @@
                       <a:r>
                         <a:rPr sz="1400" b="0" lang="zh-TW">
                           <a:solidFill>
-                            <a:srgbClr val="FFFFFF"/>
+                            <a:srgbClr val="EEE9DF"/>
                           </a:solidFill>
                           <a:latin typeface="Noto Sans TC"/>
                           <a:ea typeface="Noto Sans TC"/>
@@ -21772,20 +21772,20 @@
                     </a:lnR>
                     <a:lnT w="9525">
                       <a:solidFill>
-                        <a:srgbClr val="FFFFFF">
+                        <a:srgbClr val="EEE9DF">
                           <a:alpha val="25000"/>
                         </a:srgbClr>
                       </a:solidFill>
                     </a:lnT>
                     <a:lnB w="9525">
                       <a:solidFill>
-                        <a:srgbClr val="FFFFFF">
+                        <a:srgbClr val="EEE9DF">
                           <a:alpha val="25000"/>
                         </a:srgbClr>
                       </a:solidFill>
                     </a:lnB>
                     <a:solidFill>
-                      <a:srgbClr val="FFFFFF">
+                      <a:srgbClr val="EEE9DF">
                         <a:alpha val="8000"/>
                       </a:srgbClr>
                     </a:solidFill>
@@ -21901,10 +21901,10 @@
         <a:gradFill rotWithShape="1">
           <a:gsLst>
             <a:gs pos="0">
-              <a:srgbClr val="1F1C5C"/>
+              <a:srgbClr val="1B2632"/>
             </a:gs>
             <a:gs pos="100000">
-              <a:srgbClr val="5B1F6E"/>
+              <a:srgbClr val="2C3B4D"/>
             </a:gs>
           </a:gsLst>
           <a:lin scaled="0" ang="2700000"/>
@@ -21921,7 +21921,7 @@
       <p:grpSpPr/>
       <p:sp>
         <p:nvSpPr>
-          <p:cNvPr id="2" name="!!orb-violet"/>
+          <p:cNvPr id="2" name="!!orb-orange"/>
           <p:cNvSpPr/>
           <p:nvPr/>
         </p:nvSpPr>
@@ -21934,8 +21934,8 @@
             <a:avLst/>
           </a:prstGeom>
           <a:solidFill>
-            <a:srgbClr val="667EEA">
-              <a:alpha val="55000"/>
+            <a:srgbClr val="FFB162">
+              <a:alpha val="35000"/>
             </a:srgbClr>
           </a:solidFill>
           <a:ln>
@@ -21955,7 +21955,7 @@
       </p:sp>
       <p:sp>
         <p:nvSpPr>
-          <p:cNvPr id="3" name="!!orb-pink"/>
+          <p:cNvPr id="3" name="!!orb-rust"/>
           <p:cNvSpPr/>
           <p:nvPr/>
         </p:nvSpPr>
@@ -21968,8 +21968,8 @@
             <a:avLst/>
           </a:prstGeom>
           <a:solidFill>
-            <a:srgbClr val="F093FB">
-              <a:alpha val="45000"/>
+            <a:srgbClr val="A35139">
+              <a:alpha val="55000"/>
             </a:srgbClr>
           </a:solidFill>
           <a:ln>
@@ -21989,7 +21989,7 @@
       </p:sp>
       <p:sp>
         <p:nvSpPr>
-          <p:cNvPr id="4" name="!!orb-cyan"/>
+          <p:cNvPr id="4" name="!!orb-cream"/>
           <p:cNvSpPr/>
           <p:nvPr/>
         </p:nvSpPr>
@@ -22002,8 +22002,8 @@
             <a:avLst/>
           </a:prstGeom>
           <a:solidFill>
-            <a:srgbClr val="00F2FE">
-              <a:alpha val="30000"/>
+            <a:srgbClr val="EEE9DF">
+              <a:alpha val="12000"/>
             </a:srgbClr>
           </a:solidFill>
           <a:ln>
@@ -22047,7 +22047,7 @@
             <a:r>
               <a:rPr sz="2600" b="1" lang="zh-TW">
                 <a:solidFill>
-                  <a:srgbClr val="FFFFFF"/>
+                  <a:srgbClr val="EEE9DF"/>
                 </a:solidFill>
                 <a:effectLst>
                   <a:outerShdw blurRad="50800" dist="19050" dir="5400000" algn="ctr" rotWithShape="0">
@@ -22091,7 +22091,7 @@
             <a:r>
               <a:rPr sz="1050" b="0" lang="zh-TW">
                 <a:solidFill>
-                  <a:srgbClr val="D6D3F0"/>
+                  <a:srgbClr val="C9C1B1"/>
                 </a:solidFill>
                 <a:latin typeface="Noto Sans TC"/>
                 <a:ea typeface="Noto Sans TC"/>
@@ -22128,7 +22128,7 @@
             <a:r>
               <a:rPr sz="1050" b="0" lang="zh-TW">
                 <a:solidFill>
-                  <a:srgbClr val="D6D3F0"/>
+                  <a:srgbClr val="C9C1B1"/>
                 </a:solidFill>
                 <a:latin typeface="Noto Sans TC"/>
                 <a:ea typeface="Noto Sans TC"/>
@@ -22183,7 +22183,7 @@
             <a:r>
               <a:rPr sz="1050" b="0" lang="zh-TW">
                 <a:solidFill>
-                  <a:srgbClr val="D6D3F0"/>
+                  <a:srgbClr val="C9C1B1"/>
                 </a:solidFill>
                 <a:latin typeface="Noto Sans TC"/>
                 <a:ea typeface="Noto Sans TC"/>
@@ -22211,13 +22211,13 @@
             </a:avLst>
           </a:prstGeom>
           <a:solidFill>
-            <a:srgbClr val="FFFFFF">
+            <a:srgbClr val="EEE9DF">
               <a:alpha val="12000"/>
             </a:srgbClr>
           </a:solidFill>
           <a:ln w="9525">
             <a:solidFill>
-              <a:srgbClr val="FFFFFF">
+              <a:srgbClr val="EEE9DF">
                 <a:alpha val="35000"/>
               </a:srgbClr>
             </a:solidFill>
@@ -22264,7 +22264,7 @@
             <a:r>
               <a:rPr sz="1050" b="1" lang="zh-TW">
                 <a:solidFill>
-                  <a:srgbClr val="00F2FE"/>
+                  <a:srgbClr val="FFB162"/>
                 </a:solidFill>
                 <a:latin typeface="Noto Sans TC"/>
                 <a:ea typeface="Noto Sans TC"/>
@@ -22301,7 +22301,7 @@
             <a:r>
               <a:rPr sz="1400" b="0" lang="zh-TW">
                 <a:solidFill>
-                  <a:srgbClr val="FFFFFF"/>
+                  <a:srgbClr val="EEE9DF"/>
                 </a:solidFill>
                 <a:latin typeface="Noto Sans TC"/>
                 <a:ea typeface="Noto Sans TC"/>
@@ -22338,7 +22338,7 @@
             <a:r>
               <a:rPr sz="1050" b="1" lang="zh-TW">
                 <a:solidFill>
-                  <a:srgbClr val="00F2FE"/>
+                  <a:srgbClr val="FFB162"/>
                 </a:solidFill>
                 <a:latin typeface="Noto Sans TC"/>
                 <a:ea typeface="Noto Sans TC"/>
@@ -22375,7 +22375,7 @@
             <a:r>
               <a:rPr sz="1400" b="0" lang="zh-TW">
                 <a:solidFill>
-                  <a:srgbClr val="FFFFFF"/>
+                  <a:srgbClr val="EEE9DF"/>
                 </a:solidFill>
                 <a:latin typeface="Noto Sans TC"/>
                 <a:ea typeface="Noto Sans TC"/>
@@ -22412,7 +22412,7 @@
             <a:r>
               <a:rPr sz="1050" b="1" lang="zh-TW">
                 <a:solidFill>
-                  <a:srgbClr val="00F2FE"/>
+                  <a:srgbClr val="FFB162"/>
                 </a:solidFill>
                 <a:latin typeface="Noto Sans TC"/>
                 <a:ea typeface="Noto Sans TC"/>
@@ -22449,7 +22449,7 @@
             <a:r>
               <a:rPr sz="1400" b="0" lang="zh-TW">
                 <a:solidFill>
-                  <a:srgbClr val="FFFFFF"/>
+                  <a:srgbClr val="EEE9DF"/>
                 </a:solidFill>
                 <a:latin typeface="Noto Sans TC"/>
                 <a:ea typeface="Noto Sans TC"/>
@@ -22525,7 +22525,7 @@
                                         <p:strVal val="visible"/>
                                       </p:to>
                                     </p:set>
-                                    <p:animEffect transition="in" filter="wipe(up)">
+                                    <p:animEffect transition="in" filter="wipe(down)">
                                       <p:cBhvr>
                                         <p:cTn id="7" dur="400"/>
                                         <p:tgtEl>
@@ -22577,7 +22577,7 @@
                                         <p:strVal val="visible"/>
                                       </p:to>
                                     </p:set>
-                                    <p:animEffect transition="in" filter="wipe(up)">
+                                    <p:animEffect transition="in" filter="wipe(down)">
                                       <p:cBhvr>
                                         <p:cTn id="11" dur="400"/>
                                         <p:tgtEl>
@@ -22629,7 +22629,7 @@
                                         <p:strVal val="visible"/>
                                       </p:to>
                                     </p:set>
-                                    <p:animEffect transition="in" filter="wipe(up)">
+                                    <p:animEffect transition="in" filter="wipe(down)">
                                       <p:cBhvr>
                                         <p:cTn id="15" dur="400"/>
                                         <p:tgtEl>
@@ -22933,10 +22933,10 @@
         <a:gradFill rotWithShape="1">
           <a:gsLst>
             <a:gs pos="0">
-              <a:srgbClr val="1F1C5C"/>
+              <a:srgbClr val="1B2632"/>
             </a:gs>
             <a:gs pos="100000">
-              <a:srgbClr val="5B1F6E"/>
+              <a:srgbClr val="2C3B4D"/>
             </a:gs>
           </a:gsLst>
           <a:lin scaled="0" ang="2700000"/>
@@ -22953,7 +22953,7 @@
       <p:grpSpPr/>
       <p:sp>
         <p:nvSpPr>
-          <p:cNvPr id="2" name="!!orb-violet"/>
+          <p:cNvPr id="2" name="!!orb-orange"/>
           <p:cNvSpPr/>
           <p:nvPr/>
         </p:nvSpPr>
@@ -22966,8 +22966,8 @@
             <a:avLst/>
           </a:prstGeom>
           <a:solidFill>
-            <a:srgbClr val="667EEA">
-              <a:alpha val="55000"/>
+            <a:srgbClr val="FFB162">
+              <a:alpha val="35000"/>
             </a:srgbClr>
           </a:solidFill>
           <a:ln>
@@ -22987,7 +22987,7 @@
       </p:sp>
       <p:sp>
         <p:nvSpPr>
-          <p:cNvPr id="3" name="!!orb-pink"/>
+          <p:cNvPr id="3" name="!!orb-rust"/>
           <p:cNvSpPr/>
           <p:nvPr/>
         </p:nvSpPr>
@@ -23000,8 +23000,8 @@
             <a:avLst/>
           </a:prstGeom>
           <a:solidFill>
-            <a:srgbClr val="F093FB">
-              <a:alpha val="45000"/>
+            <a:srgbClr val="A35139">
+              <a:alpha val="55000"/>
             </a:srgbClr>
           </a:solidFill>
           <a:ln>
@@ -23021,7 +23021,7 @@
       </p:sp>
       <p:sp>
         <p:nvSpPr>
-          <p:cNvPr id="4" name="!!orb-cyan"/>
+          <p:cNvPr id="4" name="!!orb-cream"/>
           <p:cNvSpPr/>
           <p:nvPr/>
         </p:nvSpPr>
@@ -23034,8 +23034,8 @@
             <a:avLst/>
           </a:prstGeom>
           <a:solidFill>
-            <a:srgbClr val="00F2FE">
-              <a:alpha val="30000"/>
+            <a:srgbClr val="EEE9DF">
+              <a:alpha val="12000"/>
             </a:srgbClr>
           </a:solidFill>
           <a:ln>
@@ -23079,7 +23079,7 @@
             <a:r>
               <a:rPr sz="2600" b="1" lang="zh-TW">
                 <a:solidFill>
-                  <a:srgbClr val="FFFFFF"/>
+                  <a:srgbClr val="EEE9DF"/>
                 </a:solidFill>
                 <a:effectLst>
                   <a:outerShdw blurRad="50800" dist="19050" dir="5400000" algn="ctr" rotWithShape="0">
@@ -23123,7 +23123,7 @@
             <a:r>
               <a:rPr sz="1050" b="0" lang="zh-TW">
                 <a:solidFill>
-                  <a:srgbClr val="D6D3F0"/>
+                  <a:srgbClr val="C9C1B1"/>
                 </a:solidFill>
                 <a:latin typeface="Noto Sans TC"/>
                 <a:ea typeface="Noto Sans TC"/>
@@ -23160,7 +23160,7 @@
             <a:r>
               <a:rPr sz="1050" b="0" lang="zh-TW">
                 <a:solidFill>
-                  <a:srgbClr val="D6D3F0"/>
+                  <a:srgbClr val="C9C1B1"/>
                 </a:solidFill>
                 <a:latin typeface="Noto Sans TC"/>
                 <a:ea typeface="Noto Sans TC"/>
@@ -23188,13 +23188,13 @@
             </a:avLst>
           </a:prstGeom>
           <a:solidFill>
-            <a:srgbClr val="FFFFFF">
+            <a:srgbClr val="EEE9DF">
               <a:alpha val="12000"/>
             </a:srgbClr>
           </a:solidFill>
           <a:ln w="9525">
             <a:solidFill>
-              <a:srgbClr val="FFFFFF">
+              <a:srgbClr val="EEE9DF">
                 <a:alpha val="35000"/>
               </a:srgbClr>
             </a:solidFill>
@@ -23241,7 +23241,7 @@
             <a:r>
               <a:rPr sz="5400" b="1" lang="zh-TW">
                 <a:solidFill>
-                  <a:srgbClr val="FFFFFF"/>
+                  <a:srgbClr val="EEE9DF"/>
                 </a:solidFill>
                 <a:effectLst>
                   <a:outerShdw blurRad="50800" dist="19050" dir="5400000" algn="ctr" rotWithShape="0">
@@ -23285,7 +23285,7 @@
             <a:r>
               <a:rPr sz="1400" b="0" lang="zh-TW">
                 <a:solidFill>
-                  <a:srgbClr val="D6D3F0"/>
+                  <a:srgbClr val="C9C1B1"/>
                 </a:solidFill>
                 <a:latin typeface="Noto Sans TC"/>
                 <a:ea typeface="Noto Sans TC"/>
@@ -23311,7 +23311,7 @@
             <a:avLst/>
           </a:prstGeom>
           <a:solidFill>
-            <a:srgbClr val="FFFFFF">
+            <a:srgbClr val="EEE9DF">
               <a:alpha val="50000"/>
             </a:srgbClr>
           </a:solidFill>
@@ -23344,13 +23344,13 @@
             </a:avLst>
           </a:prstGeom>
           <a:solidFill>
-            <a:srgbClr val="FFFFFF">
+            <a:srgbClr val="EEE9DF">
               <a:alpha val="12000"/>
             </a:srgbClr>
           </a:solidFill>
           <a:ln w="9525">
             <a:solidFill>
-              <a:srgbClr val="FFFFFF">
+              <a:srgbClr val="EEE9DF">
                 <a:alpha val="35000"/>
               </a:srgbClr>
             </a:solidFill>
@@ -23397,7 +23397,7 @@
             <a:r>
               <a:rPr sz="5400" b="1" lang="zh-TW">
                 <a:solidFill>
-                  <a:srgbClr val="FFFFFF"/>
+                  <a:srgbClr val="EEE9DF"/>
                 </a:solidFill>
                 <a:effectLst>
                   <a:outerShdw blurRad="50800" dist="19050" dir="5400000" algn="ctr" rotWithShape="0">
@@ -23441,7 +23441,7 @@
             <a:r>
               <a:rPr sz="1400" b="0" lang="zh-TW">
                 <a:solidFill>
-                  <a:srgbClr val="D6D3F0"/>
+                  <a:srgbClr val="C9C1B1"/>
                 </a:solidFill>
                 <a:latin typeface="Noto Sans TC"/>
                 <a:ea typeface="Noto Sans TC"/>
@@ -23467,7 +23467,7 @@
             <a:avLst/>
           </a:prstGeom>
           <a:solidFill>
-            <a:srgbClr val="FFFFFF">
+            <a:srgbClr val="EEE9DF">
               <a:alpha val="50000"/>
             </a:srgbClr>
           </a:solidFill>
@@ -23500,18 +23500,18 @@
             </a:avLst>
           </a:prstGeom>
           <a:solidFill>
-            <a:srgbClr val="00F2FE">
-              <a:alpha val="20000"/>
+            <a:srgbClr val="2C3B4D">
+              <a:alpha val="85000"/>
             </a:srgbClr>
           </a:solidFill>
           <a:ln w="15875">
             <a:solidFill>
-              <a:srgbClr val="00F2FE"/>
+              <a:srgbClr val="FFB162"/>
             </a:solidFill>
           </a:ln>
           <a:effectLst>
             <a:glow rad="101600">
-              <a:srgbClr val="00F2FE">
+              <a:srgbClr val="FFB162">
                 <a:alpha val="45000"/>
               </a:srgbClr>
             </a:glow>
@@ -23556,11 +23556,11 @@
             <a:r>
               <a:rPr sz="5400" b="1" lang="zh-TW">
                 <a:solidFill>
-                  <a:srgbClr val="00F2FE"/>
+                  <a:srgbClr val="FFB162"/>
                 </a:solidFill>
                 <a:effectLst>
                   <a:glow rad="101600">
-                    <a:srgbClr val="00F2FE">
+                    <a:srgbClr val="FFB162">
                       <a:alpha val="45000"/>
                     </a:srgbClr>
                   </a:glow>
@@ -23605,7 +23605,7 @@
             <a:r>
               <a:rPr sz="1400" b="0" lang="zh-TW">
                 <a:solidFill>
-                  <a:srgbClr val="D6D3F0"/>
+                  <a:srgbClr val="C9C1B1"/>
                 </a:solidFill>
                 <a:latin typeface="Noto Sans TC"/>
                 <a:ea typeface="Noto Sans TC"/>
@@ -23642,7 +23642,7 @@
             <a:r>
               <a:rPr sz="1400" b="1" lang="zh-TW">
                 <a:solidFill>
-                  <a:srgbClr val="FFFFFF"/>
+                  <a:srgbClr val="EEE9DF"/>
                 </a:solidFill>
                 <a:latin typeface="Noto Sans TC"/>
                 <a:ea typeface="Noto Sans TC"/>
@@ -23960,7 +23960,7 @@
                                         <p:strVal val="visible"/>
                                       </p:to>
                                     </p:set>
-                                    <p:animEffect transition="in" filter="wipe(right)">
+                                    <p:animEffect transition="in" filter="wipe(left)">
                                       <p:cBhvr>
                                         <p:cTn id="23" dur="400"/>
                                         <p:tgtEl>
@@ -24256,7 +24256,7 @@
                                         <p:strVal val="visible"/>
                                       </p:to>
                                     </p:set>
-                                    <p:animEffect transition="in" filter="wipe(right)">
+                                    <p:animEffect transition="in" filter="wipe(left)">
                                       <p:cBhvr>
                                         <p:cTn id="43" dur="400"/>
                                         <p:tgtEl>

</xml_diff>